<commit_message>
docs: fix Curate/Recall flow in minimal deck and add presentation build scripts
</commit_message>
<xml_diff>
--- a/presentation/memory-kit-minimal.pptx
+++ b/presentation/memory-kit-minimal.pptx
@@ -132,301 +132,301 @@
   <pc:docChgLst>
     <pc:chgData name="OLIVEIRA MARTINEZ Jose Vicente" userId="f9383d4a-919c-4d9f-bdfe-dafed22c1cbf" providerId="ADAL" clId="{F9DEF118-A89E-43CF-AF2B-83677B5B8F7F}"/>
     <pc:docChg chg="custSel modSld">
-      <pc:chgData name="OLIVEIRA MARTINEZ Jose Vicente" userId="f9383d4a-919c-4d9f-bdfe-dafed22c1cbf" providerId="ADAL" clId="{F9DEF118-A89E-43CF-AF2B-83677B5B8F7F}" dt="2026-10-05T10:21:24.813" v="174"/>
+      <pc:chgData name="OLIVEIRA MARTINEZ Jose Vicente" userId="f9383d4a-919c-4d9f-bdfe-dafed22c1cbf" providerId="ADAL" clId="{F9DEF118-A89E-43CF-AF2B-83677B5B8F7F}" dt="2026-10-05T13:56:54.911" v="174"/>
       <pc:docMkLst>
         <pc:docMk/>
       </pc:docMkLst>
       <pc:sldChg chg="addSp modSp mod">
-        <pc:chgData name="OLIVEIRA MARTINEZ Jose Vicente" userId="f9383d4a-919c-4d9f-bdfe-dafed22c1cbf" providerId="ADAL" clId="{F9DEF118-A89E-43CF-AF2B-83677B5B8F7F}" dt="2026-10-05T10:21:23.495" v="59"/>
+        <pc:chgData name="OLIVEIRA MARTINEZ Jose Vicente" userId="f9383d4a-919c-4d9f-bdfe-dafed22c1cbf" providerId="ADAL" clId="{F9DEF118-A89E-43CF-AF2B-83677B5B8F7F}" dt="2026-10-05T13:56:53.392" v="59"/>
         <pc:sldMkLst>
           <pc:docMk/>
           <pc:sldMk cId="0" sldId="256"/>
         </pc:sldMkLst>
         <pc:picChg chg="add mod">
-          <ac:chgData name="OLIVEIRA MARTINEZ Jose Vicente" userId="f9383d4a-919c-4d9f-bdfe-dafed22c1cbf" providerId="ADAL" clId="{F9DEF118-A89E-43CF-AF2B-83677B5B8F7F}" dt="2026-10-05T10:21:22.867" v="4"/>
+          <ac:chgData name="OLIVEIRA MARTINEZ Jose Vicente" userId="f9383d4a-919c-4d9f-bdfe-dafed22c1cbf" providerId="ADAL" clId="{F9DEF118-A89E-43CF-AF2B-83677B5B8F7F}" dt="2026-10-05T13:56:52.367" v="4"/>
           <ac:picMkLst>
             <pc:docMk/>
             <pc:sldMk cId="0" sldId="256"/>
-            <ac:picMk id="35" creationId="{61668D91-F213-89CF-E578-3E3B5E5EF7EB}"/>
+            <ac:picMk id="44" creationId="{864E1B0F-D150-F29B-AEFB-EECE619C31BC}"/>
           </ac:picMkLst>
         </pc:picChg>
         <pc:picChg chg="add mod">
-          <ac:chgData name="OLIVEIRA MARTINEZ Jose Vicente" userId="f9383d4a-919c-4d9f-bdfe-dafed22c1cbf" providerId="ADAL" clId="{F9DEF118-A89E-43CF-AF2B-83677B5B8F7F}" dt="2026-10-05T10:21:22.936" v="9"/>
+          <ac:chgData name="OLIVEIRA MARTINEZ Jose Vicente" userId="f9383d4a-919c-4d9f-bdfe-dafed22c1cbf" providerId="ADAL" clId="{F9DEF118-A89E-43CF-AF2B-83677B5B8F7F}" dt="2026-10-05T13:56:52.524" v="9"/>
           <ac:picMkLst>
             <pc:docMk/>
             <pc:sldMk cId="0" sldId="256"/>
-            <ac:picMk id="37" creationId="{953F9705-B944-4896-6DD3-035AB2378804}"/>
+            <ac:picMk id="46" creationId="{BABD6173-17ED-5932-905D-07034AE6A6C1}"/>
           </ac:picMkLst>
         </pc:picChg>
         <pc:picChg chg="add mod">
-          <ac:chgData name="OLIVEIRA MARTINEZ Jose Vicente" userId="f9383d4a-919c-4d9f-bdfe-dafed22c1cbf" providerId="ADAL" clId="{F9DEF118-A89E-43CF-AF2B-83677B5B8F7F}" dt="2026-10-05T10:21:22.999" v="14"/>
+          <ac:chgData name="OLIVEIRA MARTINEZ Jose Vicente" userId="f9383d4a-919c-4d9f-bdfe-dafed22c1cbf" providerId="ADAL" clId="{F9DEF118-A89E-43CF-AF2B-83677B5B8F7F}" dt="2026-10-05T13:56:52.595" v="14"/>
           <ac:picMkLst>
             <pc:docMk/>
             <pc:sldMk cId="0" sldId="256"/>
-            <ac:picMk id="39" creationId="{E1E10CDC-0FAB-DCB1-5D94-A0324002B20F}"/>
+            <ac:picMk id="48" creationId="{46B2C76E-038E-D747-3386-CBF6DB0883C3}"/>
           </ac:picMkLst>
         </pc:picChg>
         <pc:picChg chg="add mod">
-          <ac:chgData name="OLIVEIRA MARTINEZ Jose Vicente" userId="f9383d4a-919c-4d9f-bdfe-dafed22c1cbf" providerId="ADAL" clId="{F9DEF118-A89E-43CF-AF2B-83677B5B8F7F}" dt="2026-10-05T10:21:23.048" v="19"/>
+          <ac:chgData name="OLIVEIRA MARTINEZ Jose Vicente" userId="f9383d4a-919c-4d9f-bdfe-dafed22c1cbf" providerId="ADAL" clId="{F9DEF118-A89E-43CF-AF2B-83677B5B8F7F}" dt="2026-10-05T13:56:52.673" v="19"/>
           <ac:picMkLst>
             <pc:docMk/>
             <pc:sldMk cId="0" sldId="256"/>
-            <ac:picMk id="41" creationId="{3F49A8DF-BE48-9D43-3167-91AB80CAF616}"/>
+            <ac:picMk id="50" creationId="{8E126966-DD60-7BEB-A77B-0DBCE0B10B32}"/>
           </ac:picMkLst>
         </pc:picChg>
         <pc:picChg chg="add mod">
-          <ac:chgData name="OLIVEIRA MARTINEZ Jose Vicente" userId="f9383d4a-919c-4d9f-bdfe-dafed22c1cbf" providerId="ADAL" clId="{F9DEF118-A89E-43CF-AF2B-83677B5B8F7F}" dt="2026-10-05T10:21:23.112" v="24"/>
+          <ac:chgData name="OLIVEIRA MARTINEZ Jose Vicente" userId="f9383d4a-919c-4d9f-bdfe-dafed22c1cbf" providerId="ADAL" clId="{F9DEF118-A89E-43CF-AF2B-83677B5B8F7F}" dt="2026-10-05T13:56:52.754" v="24"/>
           <ac:picMkLst>
             <pc:docMk/>
             <pc:sldMk cId="0" sldId="256"/>
-            <ac:picMk id="43" creationId="{F926440A-7B37-05B0-3D5D-CB4135578856}"/>
+            <ac:picMk id="52" creationId="{F7FD5EC1-403F-F1FB-08C6-7238604E9EB2}"/>
           </ac:picMkLst>
         </pc:picChg>
         <pc:picChg chg="add mod">
-          <ac:chgData name="OLIVEIRA MARTINEZ Jose Vicente" userId="f9383d4a-919c-4d9f-bdfe-dafed22c1cbf" providerId="ADAL" clId="{F9DEF118-A89E-43CF-AF2B-83677B5B8F7F}" dt="2026-10-05T10:21:23.169" v="29"/>
+          <ac:chgData name="OLIVEIRA MARTINEZ Jose Vicente" userId="f9383d4a-919c-4d9f-bdfe-dafed22c1cbf" providerId="ADAL" clId="{F9DEF118-A89E-43CF-AF2B-83677B5B8F7F}" dt="2026-10-05T13:56:52.819" v="29"/>
           <ac:picMkLst>
             <pc:docMk/>
             <pc:sldMk cId="0" sldId="256"/>
-            <ac:picMk id="45" creationId="{A0362B2D-658B-BC6B-531A-6541C8C1F112}"/>
+            <ac:picMk id="54" creationId="{C8586F4F-0013-DE75-B866-DA0830DF35B8}"/>
           </ac:picMkLst>
         </pc:picChg>
         <pc:picChg chg="add mod">
-          <ac:chgData name="OLIVEIRA MARTINEZ Jose Vicente" userId="f9383d4a-919c-4d9f-bdfe-dafed22c1cbf" providerId="ADAL" clId="{F9DEF118-A89E-43CF-AF2B-83677B5B8F7F}" dt="2026-10-05T10:21:23.221" v="34"/>
+          <ac:chgData name="OLIVEIRA MARTINEZ Jose Vicente" userId="f9383d4a-919c-4d9f-bdfe-dafed22c1cbf" providerId="ADAL" clId="{F9DEF118-A89E-43CF-AF2B-83677B5B8F7F}" dt="2026-10-05T13:56:52.888" v="34"/>
           <ac:picMkLst>
             <pc:docMk/>
             <pc:sldMk cId="0" sldId="256"/>
-            <ac:picMk id="47" creationId="{92162586-60B8-E0EF-247B-3245AEFD09CB}"/>
+            <ac:picMk id="56" creationId="{053058BD-3384-9BAD-2011-F0315A769DC6}"/>
           </ac:picMkLst>
         </pc:picChg>
         <pc:picChg chg="add mod">
-          <ac:chgData name="OLIVEIRA MARTINEZ Jose Vicente" userId="f9383d4a-919c-4d9f-bdfe-dafed22c1cbf" providerId="ADAL" clId="{F9DEF118-A89E-43CF-AF2B-83677B5B8F7F}" dt="2026-10-05T10:21:23.277" v="39"/>
+          <ac:chgData name="OLIVEIRA MARTINEZ Jose Vicente" userId="f9383d4a-919c-4d9f-bdfe-dafed22c1cbf" providerId="ADAL" clId="{F9DEF118-A89E-43CF-AF2B-83677B5B8F7F}" dt="2026-10-05T13:56:52.950" v="39"/>
           <ac:picMkLst>
             <pc:docMk/>
             <pc:sldMk cId="0" sldId="256"/>
-            <ac:picMk id="49" creationId="{59ADFD1A-FBA3-F887-9396-8F3D0B6D190A}"/>
+            <ac:picMk id="58" creationId="{D42D3EAD-4C74-BC2F-1437-3A98E1FFAD32}"/>
           </ac:picMkLst>
         </pc:picChg>
         <pc:picChg chg="add mod">
-          <ac:chgData name="OLIVEIRA MARTINEZ Jose Vicente" userId="f9383d4a-919c-4d9f-bdfe-dafed22c1cbf" providerId="ADAL" clId="{F9DEF118-A89E-43CF-AF2B-83677B5B8F7F}" dt="2026-10-05T10:21:23.332" v="44"/>
+          <ac:chgData name="OLIVEIRA MARTINEZ Jose Vicente" userId="f9383d4a-919c-4d9f-bdfe-dafed22c1cbf" providerId="ADAL" clId="{F9DEF118-A89E-43CF-AF2B-83677B5B8F7F}" dt="2026-10-05T13:56:53.024" v="44"/>
           <ac:picMkLst>
             <pc:docMk/>
             <pc:sldMk cId="0" sldId="256"/>
-            <ac:picMk id="51" creationId="{7CFE4560-9F65-0A7F-D139-97069F321935}"/>
+            <ac:picMk id="60" creationId="{14BE57C1-67AD-9138-FF52-0D7C64480E2E}"/>
           </ac:picMkLst>
         </pc:picChg>
         <pc:picChg chg="add mod">
-          <ac:chgData name="OLIVEIRA MARTINEZ Jose Vicente" userId="f9383d4a-919c-4d9f-bdfe-dafed22c1cbf" providerId="ADAL" clId="{F9DEF118-A89E-43CF-AF2B-83677B5B8F7F}" dt="2026-10-05T10:21:23.380" v="49"/>
+          <ac:chgData name="OLIVEIRA MARTINEZ Jose Vicente" userId="f9383d4a-919c-4d9f-bdfe-dafed22c1cbf" providerId="ADAL" clId="{F9DEF118-A89E-43CF-AF2B-83677B5B8F7F}" dt="2026-10-05T13:56:53.223" v="49"/>
           <ac:picMkLst>
             <pc:docMk/>
             <pc:sldMk cId="0" sldId="256"/>
-            <ac:picMk id="53" creationId="{49E8423E-F81F-1731-A31C-46A6CB00D6FB}"/>
+            <ac:picMk id="62" creationId="{0D8B1576-912F-D8D2-27A8-BD4F2E30CA21}"/>
           </ac:picMkLst>
         </pc:picChg>
         <pc:picChg chg="add mod">
-          <ac:chgData name="OLIVEIRA MARTINEZ Jose Vicente" userId="f9383d4a-919c-4d9f-bdfe-dafed22c1cbf" providerId="ADAL" clId="{F9DEF118-A89E-43CF-AF2B-83677B5B8F7F}" dt="2026-10-05T10:21:23.427" v="54"/>
+          <ac:chgData name="OLIVEIRA MARTINEZ Jose Vicente" userId="f9383d4a-919c-4d9f-bdfe-dafed22c1cbf" providerId="ADAL" clId="{F9DEF118-A89E-43CF-AF2B-83677B5B8F7F}" dt="2026-10-05T13:56:53.331" v="54"/>
           <ac:picMkLst>
             <pc:docMk/>
             <pc:sldMk cId="0" sldId="256"/>
-            <ac:picMk id="55" creationId="{2A1B81D3-02ED-A1C2-48D9-EDCE9B82FFC9}"/>
+            <ac:picMk id="64" creationId="{87C6DBAC-CF11-9027-536B-47A15AE17D86}"/>
           </ac:picMkLst>
         </pc:picChg>
         <pc:picChg chg="add mod">
-          <ac:chgData name="OLIVEIRA MARTINEZ Jose Vicente" userId="f9383d4a-919c-4d9f-bdfe-dafed22c1cbf" providerId="ADAL" clId="{F9DEF118-A89E-43CF-AF2B-83677B5B8F7F}" dt="2026-10-05T10:21:23.495" v="59"/>
+          <ac:chgData name="OLIVEIRA MARTINEZ Jose Vicente" userId="f9383d4a-919c-4d9f-bdfe-dafed22c1cbf" providerId="ADAL" clId="{F9DEF118-A89E-43CF-AF2B-83677B5B8F7F}" dt="2026-10-05T13:56:53.392" v="59"/>
           <ac:picMkLst>
             <pc:docMk/>
             <pc:sldMk cId="0" sldId="256"/>
-            <ac:picMk id="57" creationId="{F6C83456-8FAB-BFB8-6FAF-644F0E75ACA5}"/>
+            <ac:picMk id="66" creationId="{6B01E87B-3AA9-97EF-4C28-E652C6BAFE90}"/>
           </ac:picMkLst>
         </pc:picChg>
       </pc:sldChg>
       <pc:sldChg chg="addSp modSp mod">
-        <pc:chgData name="OLIVEIRA MARTINEZ Jose Vicente" userId="f9383d4a-919c-4d9f-bdfe-dafed22c1cbf" providerId="ADAL" clId="{F9DEF118-A89E-43CF-AF2B-83677B5B8F7F}" dt="2026-10-05T10:21:24.813" v="174"/>
+        <pc:chgData name="OLIVEIRA MARTINEZ Jose Vicente" userId="f9383d4a-919c-4d9f-bdfe-dafed22c1cbf" providerId="ADAL" clId="{F9DEF118-A89E-43CF-AF2B-83677B5B8F7F}" dt="2026-10-05T13:56:54.911" v="174"/>
         <pc:sldMkLst>
           <pc:docMk/>
           <pc:sldMk cId="0" sldId="257"/>
         </pc:sldMkLst>
         <pc:picChg chg="add mod">
-          <ac:chgData name="OLIVEIRA MARTINEZ Jose Vicente" userId="f9383d4a-919c-4d9f-bdfe-dafed22c1cbf" providerId="ADAL" clId="{F9DEF118-A89E-43CF-AF2B-83677B5B8F7F}" dt="2026-10-05T10:21:23.545" v="64"/>
+          <ac:chgData name="OLIVEIRA MARTINEZ Jose Vicente" userId="f9383d4a-919c-4d9f-bdfe-dafed22c1cbf" providerId="ADAL" clId="{F9DEF118-A89E-43CF-AF2B-83677B5B8F7F}" dt="2026-10-05T13:56:53.475" v="64"/>
           <ac:picMkLst>
             <pc:docMk/>
             <pc:sldMk cId="0" sldId="257"/>
-            <ac:picMk id="65" creationId="{C6363B6C-DA04-9247-41A7-DF7E61E92B4D}"/>
+            <ac:picMk id="65" creationId="{3DBBB61C-FB5F-6E26-2331-C9E0A89DB26F}"/>
           </ac:picMkLst>
         </pc:picChg>
         <pc:picChg chg="add mod">
-          <ac:chgData name="OLIVEIRA MARTINEZ Jose Vicente" userId="f9383d4a-919c-4d9f-bdfe-dafed22c1cbf" providerId="ADAL" clId="{F9DEF118-A89E-43CF-AF2B-83677B5B8F7F}" dt="2026-10-05T10:21:23.593" v="69"/>
+          <ac:chgData name="OLIVEIRA MARTINEZ Jose Vicente" userId="f9383d4a-919c-4d9f-bdfe-dafed22c1cbf" providerId="ADAL" clId="{F9DEF118-A89E-43CF-AF2B-83677B5B8F7F}" dt="2026-10-05T13:56:53.556" v="69"/>
           <ac:picMkLst>
             <pc:docMk/>
             <pc:sldMk cId="0" sldId="257"/>
-            <ac:picMk id="67" creationId="{2B906073-E64F-4B77-7E70-64E9BAB9286D}"/>
+            <ac:picMk id="67" creationId="{BDD98062-0A7F-C521-FADE-C64564F1BB05}"/>
           </ac:picMkLst>
         </pc:picChg>
         <pc:picChg chg="add mod">
-          <ac:chgData name="OLIVEIRA MARTINEZ Jose Vicente" userId="f9383d4a-919c-4d9f-bdfe-dafed22c1cbf" providerId="ADAL" clId="{F9DEF118-A89E-43CF-AF2B-83677B5B8F7F}" dt="2026-10-05T10:21:23.651" v="74"/>
+          <ac:chgData name="OLIVEIRA MARTINEZ Jose Vicente" userId="f9383d4a-919c-4d9f-bdfe-dafed22c1cbf" providerId="ADAL" clId="{F9DEF118-A89E-43CF-AF2B-83677B5B8F7F}" dt="2026-10-05T13:56:53.613" v="74"/>
           <ac:picMkLst>
             <pc:docMk/>
             <pc:sldMk cId="0" sldId="257"/>
-            <ac:picMk id="69" creationId="{2327D920-3B04-EC6F-2327-941B49F3CDCE}"/>
+            <ac:picMk id="69" creationId="{98CC4752-ACAB-28E3-8B1E-DC2FF024FF25}"/>
           </ac:picMkLst>
         </pc:picChg>
         <pc:picChg chg="add mod">
-          <ac:chgData name="OLIVEIRA MARTINEZ Jose Vicente" userId="f9383d4a-919c-4d9f-bdfe-dafed22c1cbf" providerId="ADAL" clId="{F9DEF118-A89E-43CF-AF2B-83677B5B8F7F}" dt="2026-10-05T10:21:23.702" v="79"/>
+          <ac:chgData name="OLIVEIRA MARTINEZ Jose Vicente" userId="f9383d4a-919c-4d9f-bdfe-dafed22c1cbf" providerId="ADAL" clId="{F9DEF118-A89E-43CF-AF2B-83677B5B8F7F}" dt="2026-10-05T13:56:53.680" v="79"/>
           <ac:picMkLst>
             <pc:docMk/>
             <pc:sldMk cId="0" sldId="257"/>
-            <ac:picMk id="71" creationId="{97885F22-EA95-311E-BB19-0DBD3726E4A7}"/>
+            <ac:picMk id="71" creationId="{BAD39808-D7D3-D784-12F3-F6C0D3DB6B5E}"/>
           </ac:picMkLst>
         </pc:picChg>
         <pc:picChg chg="add mod">
-          <ac:chgData name="OLIVEIRA MARTINEZ Jose Vicente" userId="f9383d4a-919c-4d9f-bdfe-dafed22c1cbf" providerId="ADAL" clId="{F9DEF118-A89E-43CF-AF2B-83677B5B8F7F}" dt="2026-10-05T10:21:23.751" v="84"/>
+          <ac:chgData name="OLIVEIRA MARTINEZ Jose Vicente" userId="f9383d4a-919c-4d9f-bdfe-dafed22c1cbf" providerId="ADAL" clId="{F9DEF118-A89E-43CF-AF2B-83677B5B8F7F}" dt="2026-10-05T13:56:53.731" v="84"/>
           <ac:picMkLst>
             <pc:docMk/>
             <pc:sldMk cId="0" sldId="257"/>
-            <ac:picMk id="73" creationId="{EED471F6-57FE-1B3F-F1FE-4F8EEFAFC4AE}"/>
+            <ac:picMk id="73" creationId="{6174F31A-96F8-2F34-4FC3-F04B217359F1}"/>
           </ac:picMkLst>
         </pc:picChg>
         <pc:picChg chg="add mod">
-          <ac:chgData name="OLIVEIRA MARTINEZ Jose Vicente" userId="f9383d4a-919c-4d9f-bdfe-dafed22c1cbf" providerId="ADAL" clId="{F9DEF118-A89E-43CF-AF2B-83677B5B8F7F}" dt="2026-10-05T10:21:23.807" v="89"/>
+          <ac:chgData name="OLIVEIRA MARTINEZ Jose Vicente" userId="f9383d4a-919c-4d9f-bdfe-dafed22c1cbf" providerId="ADAL" clId="{F9DEF118-A89E-43CF-AF2B-83677B5B8F7F}" dt="2026-10-05T13:56:53.794" v="89"/>
           <ac:picMkLst>
             <pc:docMk/>
             <pc:sldMk cId="0" sldId="257"/>
-            <ac:picMk id="75" creationId="{F76BF343-5868-8589-4D88-A309B20CE493}"/>
+            <ac:picMk id="75" creationId="{3079C87A-EBF5-0B15-DE98-0424C98D3C27}"/>
           </ac:picMkLst>
         </pc:picChg>
         <pc:picChg chg="add mod">
-          <ac:chgData name="OLIVEIRA MARTINEZ Jose Vicente" userId="f9383d4a-919c-4d9f-bdfe-dafed22c1cbf" providerId="ADAL" clId="{F9DEF118-A89E-43CF-AF2B-83677B5B8F7F}" dt="2026-10-05T10:21:23.862" v="94"/>
+          <ac:chgData name="OLIVEIRA MARTINEZ Jose Vicente" userId="f9383d4a-919c-4d9f-bdfe-dafed22c1cbf" providerId="ADAL" clId="{F9DEF118-A89E-43CF-AF2B-83677B5B8F7F}" dt="2026-10-05T13:56:53.846" v="94"/>
           <ac:picMkLst>
             <pc:docMk/>
             <pc:sldMk cId="0" sldId="257"/>
-            <ac:picMk id="77" creationId="{847D92CD-3183-754A-5395-13CCB807BD38}"/>
+            <ac:picMk id="77" creationId="{F81B3C03-A853-A2A3-2A38-7887C0A478A7}"/>
           </ac:picMkLst>
         </pc:picChg>
         <pc:picChg chg="add mod">
-          <ac:chgData name="OLIVEIRA MARTINEZ Jose Vicente" userId="f9383d4a-919c-4d9f-bdfe-dafed22c1cbf" providerId="ADAL" clId="{F9DEF118-A89E-43CF-AF2B-83677B5B8F7F}" dt="2026-10-05T10:21:23.919" v="99"/>
+          <ac:chgData name="OLIVEIRA MARTINEZ Jose Vicente" userId="f9383d4a-919c-4d9f-bdfe-dafed22c1cbf" providerId="ADAL" clId="{F9DEF118-A89E-43CF-AF2B-83677B5B8F7F}" dt="2026-10-05T13:56:53.909" v="99"/>
           <ac:picMkLst>
             <pc:docMk/>
             <pc:sldMk cId="0" sldId="257"/>
-            <ac:picMk id="79" creationId="{FE00C00C-BBDD-9918-D6C8-1C019857877C}"/>
+            <ac:picMk id="79" creationId="{8C858FA8-32E6-B0ED-A8A5-01260C9D17AE}"/>
           </ac:picMkLst>
         </pc:picChg>
         <pc:picChg chg="add mod">
-          <ac:chgData name="OLIVEIRA MARTINEZ Jose Vicente" userId="f9383d4a-919c-4d9f-bdfe-dafed22c1cbf" providerId="ADAL" clId="{F9DEF118-A89E-43CF-AF2B-83677B5B8F7F}" dt="2026-10-05T10:21:23.975" v="104"/>
+          <ac:chgData name="OLIVEIRA MARTINEZ Jose Vicente" userId="f9383d4a-919c-4d9f-bdfe-dafed22c1cbf" providerId="ADAL" clId="{F9DEF118-A89E-43CF-AF2B-83677B5B8F7F}" dt="2026-10-05T13:56:54.114" v="104"/>
           <ac:picMkLst>
             <pc:docMk/>
             <pc:sldMk cId="0" sldId="257"/>
-            <ac:picMk id="81" creationId="{224967DC-780A-5A9E-E9D3-7E63D649D62B}"/>
+            <ac:picMk id="81" creationId="{0803EF81-3629-4722-1879-4FE6F8D5D9A1}"/>
           </ac:picMkLst>
         </pc:picChg>
         <pc:picChg chg="add mod">
-          <ac:chgData name="OLIVEIRA MARTINEZ Jose Vicente" userId="f9383d4a-919c-4d9f-bdfe-dafed22c1cbf" providerId="ADAL" clId="{F9DEF118-A89E-43CF-AF2B-83677B5B8F7F}" dt="2026-10-05T10:21:24.028" v="109"/>
+          <ac:chgData name="OLIVEIRA MARTINEZ Jose Vicente" userId="f9383d4a-919c-4d9f-bdfe-dafed22c1cbf" providerId="ADAL" clId="{F9DEF118-A89E-43CF-AF2B-83677B5B8F7F}" dt="2026-10-05T13:56:54.179" v="109"/>
           <ac:picMkLst>
             <pc:docMk/>
             <pc:sldMk cId="0" sldId="257"/>
-            <ac:picMk id="83" creationId="{C908D301-DB80-10DD-6F03-F1B4B2EB2104}"/>
+            <ac:picMk id="83" creationId="{7E60D535-1206-EFB2-B6BC-881D27D862B0}"/>
           </ac:picMkLst>
         </pc:picChg>
         <pc:picChg chg="add mod">
-          <ac:chgData name="OLIVEIRA MARTINEZ Jose Vicente" userId="f9383d4a-919c-4d9f-bdfe-dafed22c1cbf" providerId="ADAL" clId="{F9DEF118-A89E-43CF-AF2B-83677B5B8F7F}" dt="2026-10-05T10:21:24.087" v="114"/>
+          <ac:chgData name="OLIVEIRA MARTINEZ Jose Vicente" userId="f9383d4a-919c-4d9f-bdfe-dafed22c1cbf" providerId="ADAL" clId="{F9DEF118-A89E-43CF-AF2B-83677B5B8F7F}" dt="2026-10-05T13:56:54.257" v="114"/>
           <ac:picMkLst>
             <pc:docMk/>
             <pc:sldMk cId="0" sldId="257"/>
-            <ac:picMk id="85" creationId="{F48D6BBF-501C-9B59-0107-C33393578413}"/>
+            <ac:picMk id="85" creationId="{CE82C90A-835D-9F37-0058-96970C2777EC}"/>
           </ac:picMkLst>
         </pc:picChg>
         <pc:picChg chg="add mod">
-          <ac:chgData name="OLIVEIRA MARTINEZ Jose Vicente" userId="f9383d4a-919c-4d9f-bdfe-dafed22c1cbf" providerId="ADAL" clId="{F9DEF118-A89E-43CF-AF2B-83677B5B8F7F}" dt="2026-10-05T10:21:24.133" v="119"/>
+          <ac:chgData name="OLIVEIRA MARTINEZ Jose Vicente" userId="f9383d4a-919c-4d9f-bdfe-dafed22c1cbf" providerId="ADAL" clId="{F9DEF118-A89E-43CF-AF2B-83677B5B8F7F}" dt="2026-10-05T13:56:54.310" v="119"/>
           <ac:picMkLst>
             <pc:docMk/>
             <pc:sldMk cId="0" sldId="257"/>
-            <ac:picMk id="87" creationId="{0ADECE7A-2FB0-4A48-6BF9-F4016A6B8696}"/>
+            <ac:picMk id="87" creationId="{1246FACE-805A-92B2-34F6-0F42105757E3}"/>
           </ac:picMkLst>
         </pc:picChg>
         <pc:picChg chg="add mod">
-          <ac:chgData name="OLIVEIRA MARTINEZ Jose Vicente" userId="f9383d4a-919c-4d9f-bdfe-dafed22c1cbf" providerId="ADAL" clId="{F9DEF118-A89E-43CF-AF2B-83677B5B8F7F}" dt="2026-10-05T10:21:24.195" v="124"/>
+          <ac:chgData name="OLIVEIRA MARTINEZ Jose Vicente" userId="f9383d4a-919c-4d9f-bdfe-dafed22c1cbf" providerId="ADAL" clId="{F9DEF118-A89E-43CF-AF2B-83677B5B8F7F}" dt="2026-10-05T13:56:54.358" v="124"/>
           <ac:picMkLst>
             <pc:docMk/>
             <pc:sldMk cId="0" sldId="257"/>
-            <ac:picMk id="89" creationId="{9033F62B-DD6B-D94F-D229-8720A0E273F3}"/>
+            <ac:picMk id="89" creationId="{35235251-D0AB-03AD-2BE8-3625BD1FE6FA}"/>
           </ac:picMkLst>
         </pc:picChg>
         <pc:picChg chg="add mod">
-          <ac:chgData name="OLIVEIRA MARTINEZ Jose Vicente" userId="f9383d4a-919c-4d9f-bdfe-dafed22c1cbf" providerId="ADAL" clId="{F9DEF118-A89E-43CF-AF2B-83677B5B8F7F}" dt="2026-10-05T10:21:24.258" v="129"/>
+          <ac:chgData name="OLIVEIRA MARTINEZ Jose Vicente" userId="f9383d4a-919c-4d9f-bdfe-dafed22c1cbf" providerId="ADAL" clId="{F9DEF118-A89E-43CF-AF2B-83677B5B8F7F}" dt="2026-10-05T13:56:54.410" v="129"/>
           <ac:picMkLst>
             <pc:docMk/>
             <pc:sldMk cId="0" sldId="257"/>
-            <ac:picMk id="91" creationId="{5316EA8B-05BB-87CC-0E4C-9E4E89EA6EC8}"/>
+            <ac:picMk id="91" creationId="{E0A1C567-D3D6-BBFD-72BC-14DC671706FB}"/>
           </ac:picMkLst>
         </pc:picChg>
         <pc:picChg chg="add mod">
-          <ac:chgData name="OLIVEIRA MARTINEZ Jose Vicente" userId="f9383d4a-919c-4d9f-bdfe-dafed22c1cbf" providerId="ADAL" clId="{F9DEF118-A89E-43CF-AF2B-83677B5B8F7F}" dt="2026-10-05T10:21:24.307" v="134"/>
+          <ac:chgData name="OLIVEIRA MARTINEZ Jose Vicente" userId="f9383d4a-919c-4d9f-bdfe-dafed22c1cbf" providerId="ADAL" clId="{F9DEF118-A89E-43CF-AF2B-83677B5B8F7F}" dt="2026-10-05T13:56:54.462" v="134"/>
           <ac:picMkLst>
             <pc:docMk/>
             <pc:sldMk cId="0" sldId="257"/>
-            <ac:picMk id="93" creationId="{55C13325-E587-42F3-CFC0-AA9CD02CD339}"/>
+            <ac:picMk id="93" creationId="{DF39D3D1-B8C0-019A-799E-964BDAE44D3F}"/>
           </ac:picMkLst>
         </pc:picChg>
         <pc:picChg chg="add mod">
-          <ac:chgData name="OLIVEIRA MARTINEZ Jose Vicente" userId="f9383d4a-919c-4d9f-bdfe-dafed22c1cbf" providerId="ADAL" clId="{F9DEF118-A89E-43CF-AF2B-83677B5B8F7F}" dt="2026-10-05T10:21:24.372" v="139"/>
+          <ac:chgData name="OLIVEIRA MARTINEZ Jose Vicente" userId="f9383d4a-919c-4d9f-bdfe-dafed22c1cbf" providerId="ADAL" clId="{F9DEF118-A89E-43CF-AF2B-83677B5B8F7F}" dt="2026-10-05T13:56:54.515" v="139"/>
           <ac:picMkLst>
             <pc:docMk/>
             <pc:sldMk cId="0" sldId="257"/>
-            <ac:picMk id="95" creationId="{CB66BB42-3CF1-95C6-5354-95928EBE670C}"/>
+            <ac:picMk id="95" creationId="{D9D5A74B-32D2-AD53-D4F5-C96259D19BAC}"/>
           </ac:picMkLst>
         </pc:picChg>
         <pc:picChg chg="add mod">
-          <ac:chgData name="OLIVEIRA MARTINEZ Jose Vicente" userId="f9383d4a-919c-4d9f-bdfe-dafed22c1cbf" providerId="ADAL" clId="{F9DEF118-A89E-43CF-AF2B-83677B5B8F7F}" dt="2026-10-05T10:21:24.465" v="144"/>
+          <ac:chgData name="OLIVEIRA MARTINEZ Jose Vicente" userId="f9383d4a-919c-4d9f-bdfe-dafed22c1cbf" providerId="ADAL" clId="{F9DEF118-A89E-43CF-AF2B-83677B5B8F7F}" dt="2026-10-05T13:56:54.572" v="144"/>
           <ac:picMkLst>
             <pc:docMk/>
             <pc:sldMk cId="0" sldId="257"/>
-            <ac:picMk id="97" creationId="{195709C4-A29D-9D1F-3460-BCE0B07A642E}"/>
+            <ac:picMk id="97" creationId="{EC38854F-4B72-6436-B7BE-75C71D6E3D4B}"/>
           </ac:picMkLst>
         </pc:picChg>
         <pc:picChg chg="add mod">
-          <ac:chgData name="OLIVEIRA MARTINEZ Jose Vicente" userId="f9383d4a-919c-4d9f-bdfe-dafed22c1cbf" providerId="ADAL" clId="{F9DEF118-A89E-43CF-AF2B-83677B5B8F7F}" dt="2026-10-05T10:21:24.522" v="149"/>
+          <ac:chgData name="OLIVEIRA MARTINEZ Jose Vicente" userId="f9383d4a-919c-4d9f-bdfe-dafed22c1cbf" providerId="ADAL" clId="{F9DEF118-A89E-43CF-AF2B-83677B5B8F7F}" dt="2026-10-05T13:56:54.627" v="149"/>
           <ac:picMkLst>
             <pc:docMk/>
             <pc:sldMk cId="0" sldId="257"/>
-            <ac:picMk id="99" creationId="{83C42EDD-EFCE-44DC-DCD3-9D1A6597F175}"/>
+            <ac:picMk id="99" creationId="{466B512C-A6A5-51D2-E960-715319751E6B}"/>
           </ac:picMkLst>
         </pc:picChg>
         <pc:picChg chg="add mod">
-          <ac:chgData name="OLIVEIRA MARTINEZ Jose Vicente" userId="f9383d4a-919c-4d9f-bdfe-dafed22c1cbf" providerId="ADAL" clId="{F9DEF118-A89E-43CF-AF2B-83677B5B8F7F}" dt="2026-10-05T10:21:24.593" v="154"/>
+          <ac:chgData name="OLIVEIRA MARTINEZ Jose Vicente" userId="f9383d4a-919c-4d9f-bdfe-dafed22c1cbf" providerId="ADAL" clId="{F9DEF118-A89E-43CF-AF2B-83677B5B8F7F}" dt="2026-10-05T13:56:54.689" v="154"/>
           <ac:picMkLst>
             <pc:docMk/>
             <pc:sldMk cId="0" sldId="257"/>
-            <ac:picMk id="101" creationId="{91754C1E-13F6-F25B-3BAA-2DD870EFBCDE}"/>
+            <ac:picMk id="101" creationId="{8629DDD6-8B41-42C5-C4A2-68EE78608ACA}"/>
           </ac:picMkLst>
         </pc:picChg>
         <pc:picChg chg="add mod">
-          <ac:chgData name="OLIVEIRA MARTINEZ Jose Vicente" userId="f9383d4a-919c-4d9f-bdfe-dafed22c1cbf" providerId="ADAL" clId="{F9DEF118-A89E-43CF-AF2B-83677B5B8F7F}" dt="2026-10-05T10:21:24.643" v="159"/>
+          <ac:chgData name="OLIVEIRA MARTINEZ Jose Vicente" userId="f9383d4a-919c-4d9f-bdfe-dafed22c1cbf" providerId="ADAL" clId="{F9DEF118-A89E-43CF-AF2B-83677B5B8F7F}" dt="2026-10-05T13:56:54.744" v="159"/>
           <ac:picMkLst>
             <pc:docMk/>
             <pc:sldMk cId="0" sldId="257"/>
-            <ac:picMk id="103" creationId="{978E81E1-4E5F-D9C8-B9C0-B2BFE965F933}"/>
+            <ac:picMk id="103" creationId="{C70AECB7-F5CE-3D30-C4F3-51B7853DAC74}"/>
           </ac:picMkLst>
         </pc:picChg>
         <pc:picChg chg="add mod">
-          <ac:chgData name="OLIVEIRA MARTINEZ Jose Vicente" userId="f9383d4a-919c-4d9f-bdfe-dafed22c1cbf" providerId="ADAL" clId="{F9DEF118-A89E-43CF-AF2B-83677B5B8F7F}" dt="2026-10-05T10:21:24.696" v="164"/>
+          <ac:chgData name="OLIVEIRA MARTINEZ Jose Vicente" userId="f9383d4a-919c-4d9f-bdfe-dafed22c1cbf" providerId="ADAL" clId="{F9DEF118-A89E-43CF-AF2B-83677B5B8F7F}" dt="2026-10-05T13:56:54.814" v="164"/>
           <ac:picMkLst>
             <pc:docMk/>
             <pc:sldMk cId="0" sldId="257"/>
-            <ac:picMk id="105" creationId="{7D9E5097-6798-B89D-6F3A-DD5A2A56251F}"/>
+            <ac:picMk id="105" creationId="{3A89CF81-D623-57B0-95CB-6F6500A7D91B}"/>
           </ac:picMkLst>
         </pc:picChg>
         <pc:picChg chg="add mod">
-          <ac:chgData name="OLIVEIRA MARTINEZ Jose Vicente" userId="f9383d4a-919c-4d9f-bdfe-dafed22c1cbf" providerId="ADAL" clId="{F9DEF118-A89E-43CF-AF2B-83677B5B8F7F}" dt="2026-10-05T10:21:24.761" v="169"/>
+          <ac:chgData name="OLIVEIRA MARTINEZ Jose Vicente" userId="f9383d4a-919c-4d9f-bdfe-dafed22c1cbf" providerId="ADAL" clId="{F9DEF118-A89E-43CF-AF2B-83677B5B8F7F}" dt="2026-10-05T13:56:54.861" v="169"/>
           <ac:picMkLst>
             <pc:docMk/>
             <pc:sldMk cId="0" sldId="257"/>
-            <ac:picMk id="107" creationId="{B10374C6-C350-0AE5-39C0-4097269518AF}"/>
+            <ac:picMk id="107" creationId="{FC9CE735-0D0B-E538-107C-417B6E57E14C}"/>
           </ac:picMkLst>
         </pc:picChg>
         <pc:picChg chg="add mod">
-          <ac:chgData name="OLIVEIRA MARTINEZ Jose Vicente" userId="f9383d4a-919c-4d9f-bdfe-dafed22c1cbf" providerId="ADAL" clId="{F9DEF118-A89E-43CF-AF2B-83677B5B8F7F}" dt="2026-10-05T10:21:24.813" v="174"/>
+          <ac:chgData name="OLIVEIRA MARTINEZ Jose Vicente" userId="f9383d4a-919c-4d9f-bdfe-dafed22c1cbf" providerId="ADAL" clId="{F9DEF118-A89E-43CF-AF2B-83677B5B8F7F}" dt="2026-10-05T13:56:54.911" v="174"/>
           <ac:picMkLst>
             <pc:docMk/>
             <pc:sldMk cId="0" sldId="257"/>
-            <ac:picMk id="109" creationId="{751ECD32-F31B-6E86-6F9E-1A901E50B22B}"/>
+            <ac:picMk id="109" creationId="{C7951127-6BF8-AE4A-1E3C-B7A72D9DD7DC}"/>
           </ac:picMkLst>
         </pc:picChg>
       </pc:sldChg>
@@ -460,7 +460,7 @@
     </p:spTree>
     <p:extLst>
       <p:ext uri="{BB962C8B-B14F-4D97-AF65-F5344CB8AC3E}">
-        <p14:creationId xmlns:p14="http://schemas.microsoft.com/office/powerpoint/2010/main" val="3902486067"/>
+        <p14:creationId xmlns:p14="http://schemas.microsoft.com/office/powerpoint/2010/main" val="101724641"/>
       </p:ext>
     </p:extLst>
   </p:cSld>
@@ -710,7 +710,12 @@
           </a:p>
           <a:p>
             <a:r>
-              <a:t>[8:30–11:00] CURATE — teal arc (sparkles + approval badge)</a:t>
+              <a:t>[8:30–11:00] CURATE — teal line leaving the chat (sparkles + approval badge), reaching all four levels</a:t>
+            </a:r>
+          </a:p>
+          <a:p>
+            <a:r>
+              <a:t>- You ask for it in the chat; Curate then looks at every level at once: L0 to L3.</a:t>
             </a:r>
           </a:p>
           <a:p>
@@ -738,12 +743,12 @@
           </a:p>
           <a:p>
             <a:r>
-              <a:t>[11:00–13:00] RECALL — blue arc back to the chat (magnifier)</a:t>
-            </a:r>
-          </a:p>
-          <a:p>
-            <a:r>
-              <a:t>- At the start of every task: a read-only briefing from all levels plus the code.</a:t>
+              <a:t>[11:00–13:00] RECALL — blue line collecting from all four levels, back to the chat (magnifier)</a:t>
+            </a:r>
+          </a:p>
+          <a:p>
+            <a:r>
+              <a:t>- At the start of every task: a read-only briefing built from L0 to L3 plus the code, delivered into the chat.</a:t>
             </a:r>
           </a:p>
           <a:p>
@@ -4272,265 +4277,371 @@
           </a:fontRef>
         </p:style>
       </p:cxnSp>
-      <p:sp>
-        <p:nvSpPr>
-          <p:cNvPr id="12" name="Freeform 11"/>
-          <p:cNvSpPr/>
-          <p:nvPr/>
-        </p:nvSpPr>
-        <p:spPr>
-          <a:xfrm>
-            <a:off x="5031066" y="1908343"/>
-            <a:ext cx="5391227" cy="1061590"/>
-          </a:xfrm>
-          <a:custGeom>
-            <a:avLst/>
-            <a:gdLst/>
-            <a:ahLst/>
-            <a:cxnLst/>
-            <a:rect l="l" t="t" r="r" b="b"/>
-            <a:pathLst>
-              <a:path w="5391227" h="1061590">
-                <a:moveTo>
-                  <a:pt x="0" y="1061590"/>
-                </a:moveTo>
-                <a:lnTo>
-                  <a:pt x="32436" y="996278"/>
-                </a:lnTo>
-                <a:lnTo>
-                  <a:pt x="69805" y="933038"/>
-                </a:lnTo>
-                <a:lnTo>
-                  <a:pt x="111949" y="871872"/>
-                </a:lnTo>
-                <a:lnTo>
-                  <a:pt x="158709" y="812780"/>
-                </a:lnTo>
-                <a:lnTo>
-                  <a:pt x="209924" y="755761"/>
-                </a:lnTo>
-                <a:lnTo>
-                  <a:pt x="265436" y="700815"/>
-                </a:lnTo>
-                <a:lnTo>
-                  <a:pt x="325086" y="647943"/>
-                </a:lnTo>
-                <a:lnTo>
-                  <a:pt x="388714" y="597144"/>
-                </a:lnTo>
-                <a:lnTo>
-                  <a:pt x="456163" y="548419"/>
-                </a:lnTo>
-                <a:lnTo>
-                  <a:pt x="527271" y="501767"/>
-                </a:lnTo>
-                <a:lnTo>
-                  <a:pt x="601881" y="457189"/>
-                </a:lnTo>
-                <a:lnTo>
-                  <a:pt x="679832" y="414684"/>
-                </a:lnTo>
-                <a:lnTo>
-                  <a:pt x="760967" y="374252"/>
-                </a:lnTo>
-                <a:lnTo>
-                  <a:pt x="845125" y="335894"/>
-                </a:lnTo>
-                <a:lnTo>
-                  <a:pt x="932148" y="299609"/>
-                </a:lnTo>
-                <a:lnTo>
-                  <a:pt x="1021877" y="265397"/>
-                </a:lnTo>
-                <a:lnTo>
-                  <a:pt x="1114151" y="233260"/>
-                </a:lnTo>
-                <a:lnTo>
-                  <a:pt x="1208813" y="203195"/>
-                </a:lnTo>
-                <a:lnTo>
-                  <a:pt x="1305703" y="175204"/>
-                </a:lnTo>
-                <a:lnTo>
-                  <a:pt x="1404662" y="149286"/>
-                </a:lnTo>
-                <a:lnTo>
-                  <a:pt x="1505531" y="125442"/>
-                </a:lnTo>
-                <a:lnTo>
-                  <a:pt x="1608150" y="103671"/>
-                </a:lnTo>
-                <a:lnTo>
-                  <a:pt x="1712361" y="83973"/>
-                </a:lnTo>
-                <a:lnTo>
-                  <a:pt x="1818004" y="66349"/>
-                </a:lnTo>
-                <a:lnTo>
-                  <a:pt x="1924920" y="50799"/>
-                </a:lnTo>
-                <a:lnTo>
-                  <a:pt x="2032950" y="37321"/>
-                </a:lnTo>
-                <a:lnTo>
-                  <a:pt x="2141935" y="25918"/>
-                </a:lnTo>
-                <a:lnTo>
-                  <a:pt x="2251716" y="16587"/>
-                </a:lnTo>
-                <a:lnTo>
-                  <a:pt x="2362133" y="9330"/>
-                </a:lnTo>
-                <a:lnTo>
-                  <a:pt x="2473028" y="4147"/>
-                </a:lnTo>
-                <a:lnTo>
-                  <a:pt x="2584241" y="1037"/>
-                </a:lnTo>
-                <a:lnTo>
-                  <a:pt x="2695613" y="0"/>
-                </a:lnTo>
-                <a:lnTo>
-                  <a:pt x="2806986" y="1037"/>
-                </a:lnTo>
-                <a:lnTo>
-                  <a:pt x="2918199" y="4147"/>
-                </a:lnTo>
-                <a:lnTo>
-                  <a:pt x="3029094" y="9330"/>
-                </a:lnTo>
-                <a:lnTo>
-                  <a:pt x="3139511" y="16587"/>
-                </a:lnTo>
-                <a:lnTo>
-                  <a:pt x="3249292" y="25918"/>
-                </a:lnTo>
-                <a:lnTo>
-                  <a:pt x="3358277" y="37321"/>
-                </a:lnTo>
-                <a:lnTo>
-                  <a:pt x="3466307" y="50799"/>
-                </a:lnTo>
-                <a:lnTo>
-                  <a:pt x="3573223" y="66349"/>
-                </a:lnTo>
-                <a:lnTo>
-                  <a:pt x="3678866" y="83973"/>
-                </a:lnTo>
-                <a:lnTo>
-                  <a:pt x="3783077" y="103671"/>
-                </a:lnTo>
-                <a:lnTo>
-                  <a:pt x="3885696" y="125442"/>
-                </a:lnTo>
-                <a:lnTo>
-                  <a:pt x="3986565" y="149286"/>
-                </a:lnTo>
-                <a:lnTo>
-                  <a:pt x="4085524" y="175204"/>
-                </a:lnTo>
-                <a:lnTo>
-                  <a:pt x="4182414" y="203195"/>
-                </a:lnTo>
-                <a:lnTo>
-                  <a:pt x="4277076" y="233260"/>
-                </a:lnTo>
-                <a:lnTo>
-                  <a:pt x="4369350" y="265397"/>
-                </a:lnTo>
-                <a:lnTo>
-                  <a:pt x="4459079" y="299609"/>
-                </a:lnTo>
-                <a:lnTo>
-                  <a:pt x="4546102" y="335894"/>
-                </a:lnTo>
-                <a:lnTo>
-                  <a:pt x="4630260" y="374252"/>
-                </a:lnTo>
-                <a:lnTo>
-                  <a:pt x="4711395" y="414684"/>
-                </a:lnTo>
-                <a:lnTo>
-                  <a:pt x="4789346" y="457189"/>
-                </a:lnTo>
-                <a:lnTo>
-                  <a:pt x="4863956" y="501767"/>
-                </a:lnTo>
-                <a:lnTo>
-                  <a:pt x="4935064" y="548419"/>
-                </a:lnTo>
-                <a:lnTo>
-                  <a:pt x="5002513" y="597144"/>
-                </a:lnTo>
-                <a:lnTo>
-                  <a:pt x="5066141" y="647943"/>
-                </a:lnTo>
-                <a:lnTo>
-                  <a:pt x="5125791" y="700815"/>
-                </a:lnTo>
-                <a:lnTo>
-                  <a:pt x="5181303" y="755761"/>
-                </a:lnTo>
-                <a:lnTo>
-                  <a:pt x="5232518" y="812780"/>
-                </a:lnTo>
-                <a:lnTo>
-                  <a:pt x="5279278" y="871872"/>
-                </a:lnTo>
-                <a:lnTo>
-                  <a:pt x="5321422" y="933038"/>
-                </a:lnTo>
-                <a:lnTo>
-                  <a:pt x="5358791" y="996278"/>
-                </a:lnTo>
-                <a:lnTo>
-                  <a:pt x="5391227" y="1061590"/>
-                </a:lnTo>
-              </a:path>
-            </a:pathLst>
-          </a:custGeom>
-          <a:noFill/>
+      <p:cxnSp>
+        <p:nvCxnSpPr>
+          <p:cNvPr id="12" name="Connector 11"/>
+          <p:cNvCxnSpPr/>
+          <p:nvPr/>
+        </p:nvCxnSpPr>
+        <p:spPr>
+          <a:xfrm flipV="1">
+            <a:off x="1417320" y="2423160"/>
+            <a:ext cx="0" cy="338328"/>
+          </a:xfrm>
+          <a:prstGeom prst="line">
+            <a:avLst/>
+          </a:prstGeom>
           <a:ln w="34925" cap="rnd">
             <a:solidFill>
               <a:srgbClr val="2A9D8F"/>
             </a:solidFill>
             <a:tailEnd type="triangle" w="med" len="med"/>
           </a:ln>
-          <a:effectLst/>
         </p:spPr>
         <p:style>
-          <a:lnRef idx="1">
+          <a:lnRef idx="2">
             <a:schemeClr val="accent1"/>
           </a:lnRef>
-          <a:fillRef idx="3">
+          <a:fillRef idx="0">
             <a:schemeClr val="accent1"/>
           </a:fillRef>
-          <a:effectRef idx="2">
+          <a:effectRef idx="1">
             <a:schemeClr val="accent1"/>
           </a:effectRef>
           <a:fontRef idx="minor">
-            <a:schemeClr val="lt1"/>
+            <a:schemeClr val="tx1"/>
           </a:fontRef>
         </p:style>
-        <p:txBody>
-          <a:bodyPr rtlCol="0" anchor="ctr"/>
-          <a:lstStyle/>
-          <a:p>
-            <a:pPr algn="ctr"/>
-            <a:endParaRPr/>
-          </a:p>
-        </p:txBody>
-      </p:sp>
-      <p:sp>
-        <p:nvSpPr>
-          <p:cNvPr id="13" name="Freeform 12"/>
+      </p:cxnSp>
+      <p:cxnSp>
+        <p:nvCxnSpPr>
+          <p:cNvPr id="13" name="Connector 12"/>
+          <p:cNvCxnSpPr/>
+          <p:nvPr/>
+        </p:nvCxnSpPr>
+        <p:spPr>
+          <a:xfrm>
+            <a:off x="1417320" y="2011680"/>
+            <a:ext cx="9464040" cy="0"/>
+          </a:xfrm>
+          <a:prstGeom prst="line">
+            <a:avLst/>
+          </a:prstGeom>
+          <a:ln w="34925" cap="rnd">
+            <a:solidFill>
+              <a:srgbClr val="2A9D8F"/>
+            </a:solidFill>
+          </a:ln>
+        </p:spPr>
+        <p:style>
+          <a:lnRef idx="2">
+            <a:schemeClr val="accent1"/>
+          </a:lnRef>
+          <a:fillRef idx="0">
+            <a:schemeClr val="accent1"/>
+          </a:fillRef>
+          <a:effectRef idx="1">
+            <a:schemeClr val="accent1"/>
+          </a:effectRef>
+          <a:fontRef idx="minor">
+            <a:schemeClr val="tx1"/>
+          </a:fontRef>
+        </p:style>
+      </p:cxnSp>
+      <p:cxnSp>
+        <p:nvCxnSpPr>
+          <p:cNvPr id="14" name="Connector 13"/>
+          <p:cNvCxnSpPr/>
+          <p:nvPr/>
+        </p:nvCxnSpPr>
+        <p:spPr>
+          <a:xfrm>
+            <a:off x="4572000" y="2011680"/>
+            <a:ext cx="0" cy="749808"/>
+          </a:xfrm>
+          <a:prstGeom prst="line">
+            <a:avLst/>
+          </a:prstGeom>
+          <a:ln w="34925" cap="rnd">
+            <a:solidFill>
+              <a:srgbClr val="2A9D8F"/>
+            </a:solidFill>
+            <a:tailEnd type="triangle" w="med" len="med"/>
+          </a:ln>
+        </p:spPr>
+        <p:style>
+          <a:lnRef idx="2">
+            <a:schemeClr val="accent1"/>
+          </a:lnRef>
+          <a:fillRef idx="0">
+            <a:schemeClr val="accent1"/>
+          </a:fillRef>
+          <a:effectRef idx="1">
+            <a:schemeClr val="accent1"/>
+          </a:effectRef>
+          <a:fontRef idx="minor">
+            <a:schemeClr val="tx1"/>
+          </a:fontRef>
+        </p:style>
+      </p:cxnSp>
+      <p:cxnSp>
+        <p:nvCxnSpPr>
+          <p:cNvPr id="15" name="Connector 14"/>
+          <p:cNvCxnSpPr/>
+          <p:nvPr/>
+        </p:nvCxnSpPr>
+        <p:spPr>
+          <a:xfrm>
+            <a:off x="6675120" y="2011680"/>
+            <a:ext cx="0" cy="749808"/>
+          </a:xfrm>
+          <a:prstGeom prst="line">
+            <a:avLst/>
+          </a:prstGeom>
+          <a:ln w="34925" cap="rnd">
+            <a:solidFill>
+              <a:srgbClr val="2A9D8F"/>
+            </a:solidFill>
+            <a:tailEnd type="triangle" w="med" len="med"/>
+          </a:ln>
+        </p:spPr>
+        <p:style>
+          <a:lnRef idx="2">
+            <a:schemeClr val="accent1"/>
+          </a:lnRef>
+          <a:fillRef idx="0">
+            <a:schemeClr val="accent1"/>
+          </a:fillRef>
+          <a:effectRef idx="1">
+            <a:schemeClr val="accent1"/>
+          </a:effectRef>
+          <a:fontRef idx="minor">
+            <a:schemeClr val="tx1"/>
+          </a:fontRef>
+        </p:style>
+      </p:cxnSp>
+      <p:cxnSp>
+        <p:nvCxnSpPr>
+          <p:cNvPr id="16" name="Connector 15"/>
+          <p:cNvCxnSpPr/>
+          <p:nvPr/>
+        </p:nvCxnSpPr>
+        <p:spPr>
+          <a:xfrm>
+            <a:off x="8778240" y="2011680"/>
+            <a:ext cx="0" cy="749808"/>
+          </a:xfrm>
+          <a:prstGeom prst="line">
+            <a:avLst/>
+          </a:prstGeom>
+          <a:ln w="34925" cap="rnd">
+            <a:solidFill>
+              <a:srgbClr val="2A9D8F"/>
+            </a:solidFill>
+            <a:tailEnd type="triangle" w="med" len="med"/>
+          </a:ln>
+        </p:spPr>
+        <p:style>
+          <a:lnRef idx="2">
+            <a:schemeClr val="accent1"/>
+          </a:lnRef>
+          <a:fillRef idx="0">
+            <a:schemeClr val="accent1"/>
+          </a:fillRef>
+          <a:effectRef idx="1">
+            <a:schemeClr val="accent1"/>
+          </a:effectRef>
+          <a:fontRef idx="minor">
+            <a:schemeClr val="tx1"/>
+          </a:fontRef>
+        </p:style>
+      </p:cxnSp>
+      <p:cxnSp>
+        <p:nvCxnSpPr>
+          <p:cNvPr id="17" name="Connector 16"/>
+          <p:cNvCxnSpPr/>
+          <p:nvPr/>
+        </p:nvCxnSpPr>
+        <p:spPr>
+          <a:xfrm>
+            <a:off x="10881360" y="2011680"/>
+            <a:ext cx="0" cy="749808"/>
+          </a:xfrm>
+          <a:prstGeom prst="line">
+            <a:avLst/>
+          </a:prstGeom>
+          <a:ln w="34925" cap="rnd">
+            <a:solidFill>
+              <a:srgbClr val="2A9D8F"/>
+            </a:solidFill>
+            <a:tailEnd type="triangle" w="med" len="med"/>
+          </a:ln>
+        </p:spPr>
+        <p:style>
+          <a:lnRef idx="2">
+            <a:schemeClr val="accent1"/>
+          </a:lnRef>
+          <a:fillRef idx="0">
+            <a:schemeClr val="accent1"/>
+          </a:fillRef>
+          <a:effectRef idx="1">
+            <a:schemeClr val="accent1"/>
+          </a:effectRef>
+          <a:fontRef idx="minor">
+            <a:schemeClr val="tx1"/>
+          </a:fontRef>
+        </p:style>
+      </p:cxnSp>
+      <p:cxnSp>
+        <p:nvCxnSpPr>
+          <p:cNvPr id="18" name="Connector 17"/>
+          <p:cNvCxnSpPr/>
+          <p:nvPr/>
+        </p:nvCxnSpPr>
+        <p:spPr>
+          <a:xfrm>
+            <a:off x="4572000" y="4718304"/>
+            <a:ext cx="0" cy="493776"/>
+          </a:xfrm>
+          <a:prstGeom prst="line">
+            <a:avLst/>
+          </a:prstGeom>
+          <a:ln w="34925" cap="rnd">
+            <a:solidFill>
+              <a:srgbClr val="1D4E89"/>
+            </a:solidFill>
+          </a:ln>
+        </p:spPr>
+        <p:style>
+          <a:lnRef idx="2">
+            <a:schemeClr val="accent1"/>
+          </a:lnRef>
+          <a:fillRef idx="0">
+            <a:schemeClr val="accent1"/>
+          </a:fillRef>
+          <a:effectRef idx="1">
+            <a:schemeClr val="accent1"/>
+          </a:effectRef>
+          <a:fontRef idx="minor">
+            <a:schemeClr val="tx1"/>
+          </a:fontRef>
+        </p:style>
+      </p:cxnSp>
+      <p:cxnSp>
+        <p:nvCxnSpPr>
+          <p:cNvPr id="19" name="Connector 18"/>
+          <p:cNvCxnSpPr/>
+          <p:nvPr/>
+        </p:nvCxnSpPr>
+        <p:spPr>
+          <a:xfrm>
+            <a:off x="6675120" y="4718304"/>
+            <a:ext cx="0" cy="493776"/>
+          </a:xfrm>
+          <a:prstGeom prst="line">
+            <a:avLst/>
+          </a:prstGeom>
+          <a:ln w="34925" cap="rnd">
+            <a:solidFill>
+              <a:srgbClr val="1D4E89"/>
+            </a:solidFill>
+          </a:ln>
+        </p:spPr>
+        <p:style>
+          <a:lnRef idx="2">
+            <a:schemeClr val="accent1"/>
+          </a:lnRef>
+          <a:fillRef idx="0">
+            <a:schemeClr val="accent1"/>
+          </a:fillRef>
+          <a:effectRef idx="1">
+            <a:schemeClr val="accent1"/>
+          </a:effectRef>
+          <a:fontRef idx="minor">
+            <a:schemeClr val="tx1"/>
+          </a:fontRef>
+        </p:style>
+      </p:cxnSp>
+      <p:cxnSp>
+        <p:nvCxnSpPr>
+          <p:cNvPr id="20" name="Connector 19"/>
+          <p:cNvCxnSpPr/>
+          <p:nvPr/>
+        </p:nvCxnSpPr>
+        <p:spPr>
+          <a:xfrm>
+            <a:off x="8778240" y="4718304"/>
+            <a:ext cx="0" cy="493776"/>
+          </a:xfrm>
+          <a:prstGeom prst="line">
+            <a:avLst/>
+          </a:prstGeom>
+          <a:ln w="34925" cap="rnd">
+            <a:solidFill>
+              <a:srgbClr val="1D4E89"/>
+            </a:solidFill>
+          </a:ln>
+        </p:spPr>
+        <p:style>
+          <a:lnRef idx="2">
+            <a:schemeClr val="accent1"/>
+          </a:lnRef>
+          <a:fillRef idx="0">
+            <a:schemeClr val="accent1"/>
+          </a:fillRef>
+          <a:effectRef idx="1">
+            <a:schemeClr val="accent1"/>
+          </a:effectRef>
+          <a:fontRef idx="minor">
+            <a:schemeClr val="tx1"/>
+          </a:fontRef>
+        </p:style>
+      </p:cxnSp>
+      <p:cxnSp>
+        <p:nvCxnSpPr>
+          <p:cNvPr id="21" name="Connector 20"/>
+          <p:cNvCxnSpPr/>
+          <p:nvPr/>
+        </p:nvCxnSpPr>
+        <p:spPr>
+          <a:xfrm>
+            <a:off x="10881360" y="4718304"/>
+            <a:ext cx="0" cy="493776"/>
+          </a:xfrm>
+          <a:prstGeom prst="line">
+            <a:avLst/>
+          </a:prstGeom>
+          <a:ln w="34925" cap="rnd">
+            <a:solidFill>
+              <a:srgbClr val="1D4E89"/>
+            </a:solidFill>
+          </a:ln>
+        </p:spPr>
+        <p:style>
+          <a:lnRef idx="2">
+            <a:schemeClr val="accent1"/>
+          </a:lnRef>
+          <a:fillRef idx="0">
+            <a:schemeClr val="accent1"/>
+          </a:fillRef>
+          <a:effectRef idx="1">
+            <a:schemeClr val="accent1"/>
+          </a:effectRef>
+          <a:fontRef idx="minor">
+            <a:schemeClr val="tx1"/>
+          </a:fontRef>
+        </p:style>
+      </p:cxnSp>
+      <p:sp>
+        <p:nvSpPr>
+          <p:cNvPr id="22" name="Freeform 21"/>
           <p:cNvSpPr/>
           <p:nvPr/>
         </p:nvSpPr>
         <p:spPr>
           <a:xfrm>
-            <a:off x="1876386" y="3888066"/>
-            <a:ext cx="8545907" cy="1233040"/>
+            <a:off x="1417320" y="4517136"/>
+            <a:ext cx="9464040" cy="694944"/>
           </a:xfrm>
           <a:custGeom>
             <a:avLst/>
@@ -4539,198 +4650,12 @@
             <a:cxnLst/>
             <a:rect l="l" t="t" r="r" b="b"/>
             <a:pathLst>
-              <a:path w="8545907" h="1233040">
+              <a:path w="9464040" h="694944">
                 <a:moveTo>
-                  <a:pt x="8545907" y="0"/>
+                  <a:pt x="9464040" y="694944"/>
                 </a:moveTo>
                 <a:lnTo>
-                  <a:pt x="8507097" y="75861"/>
-                </a:lnTo>
-                <a:lnTo>
-                  <a:pt x="8459266" y="149313"/>
-                </a:lnTo>
-                <a:lnTo>
-                  <a:pt x="8402705" y="220358"/>
-                </a:lnTo>
-                <a:lnTo>
-                  <a:pt x="8337706" y="288994"/>
-                </a:lnTo>
-                <a:lnTo>
-                  <a:pt x="8264558" y="355221"/>
-                </a:lnTo>
-                <a:lnTo>
-                  <a:pt x="8183553" y="419041"/>
-                </a:lnTo>
-                <a:lnTo>
-                  <a:pt x="8094983" y="480452"/>
-                </a:lnTo>
-                <a:lnTo>
-                  <a:pt x="7999137" y="539455"/>
-                </a:lnTo>
-                <a:lnTo>
-                  <a:pt x="7896308" y="596050"/>
-                </a:lnTo>
-                <a:lnTo>
-                  <a:pt x="7786785" y="650236"/>
-                </a:lnTo>
-                <a:lnTo>
-                  <a:pt x="7670861" y="702014"/>
-                </a:lnTo>
-                <a:lnTo>
-                  <a:pt x="7548825" y="751384"/>
-                </a:lnTo>
-                <a:lnTo>
-                  <a:pt x="7420970" y="798345"/>
-                </a:lnTo>
-                <a:lnTo>
-                  <a:pt x="7287586" y="842898"/>
-                </a:lnTo>
-                <a:lnTo>
-                  <a:pt x="7148963" y="885043"/>
-                </a:lnTo>
-                <a:lnTo>
-                  <a:pt x="7005394" y="924780"/>
-                </a:lnTo>
-                <a:lnTo>
-                  <a:pt x="6857169" y="962108"/>
-                </a:lnTo>
-                <a:lnTo>
-                  <a:pt x="6704579" y="997028"/>
-                </a:lnTo>
-                <a:lnTo>
-                  <a:pt x="6547915" y="1029540"/>
-                </a:lnTo>
-                <a:lnTo>
-                  <a:pt x="6387467" y="1059644"/>
-                </a:lnTo>
-                <a:lnTo>
-                  <a:pt x="6223528" y="1087339"/>
-                </a:lnTo>
-                <a:lnTo>
-                  <a:pt x="6056388" y="1112626"/>
-                </a:lnTo>
-                <a:lnTo>
-                  <a:pt x="5886338" y="1135505"/>
-                </a:lnTo>
-                <a:lnTo>
-                  <a:pt x="5713669" y="1155975"/>
-                </a:lnTo>
-                <a:lnTo>
-                  <a:pt x="5538672" y="1174037"/>
-                </a:lnTo>
-                <a:lnTo>
-                  <a:pt x="5361638" y="1189691"/>
-                </a:lnTo>
-                <a:lnTo>
-                  <a:pt x="5182858" y="1202937"/>
-                </a:lnTo>
-                <a:lnTo>
-                  <a:pt x="5002623" y="1213774"/>
-                </a:lnTo>
-                <a:lnTo>
-                  <a:pt x="4821224" y="1222203"/>
-                </a:lnTo>
-                <a:lnTo>
-                  <a:pt x="4638952" y="1228224"/>
-                </a:lnTo>
-                <a:lnTo>
-                  <a:pt x="4456098" y="1231836"/>
-                </a:lnTo>
-                <a:lnTo>
-                  <a:pt x="4272954" y="1233040"/>
-                </a:lnTo>
-                <a:lnTo>
-                  <a:pt x="4089809" y="1231836"/>
-                </a:lnTo>
-                <a:lnTo>
-                  <a:pt x="3906955" y="1228224"/>
-                </a:lnTo>
-                <a:lnTo>
-                  <a:pt x="3724683" y="1222203"/>
-                </a:lnTo>
-                <a:lnTo>
-                  <a:pt x="3543284" y="1213774"/>
-                </a:lnTo>
-                <a:lnTo>
-                  <a:pt x="3363049" y="1202937"/>
-                </a:lnTo>
-                <a:lnTo>
-                  <a:pt x="3184269" y="1189691"/>
-                </a:lnTo>
-                <a:lnTo>
-                  <a:pt x="3007235" y="1174037"/>
-                </a:lnTo>
-                <a:lnTo>
-                  <a:pt x="2832238" y="1155975"/>
-                </a:lnTo>
-                <a:lnTo>
-                  <a:pt x="2659569" y="1135505"/>
-                </a:lnTo>
-                <a:lnTo>
-                  <a:pt x="2489519" y="1112626"/>
-                </a:lnTo>
-                <a:lnTo>
-                  <a:pt x="2322379" y="1087339"/>
-                </a:lnTo>
-                <a:lnTo>
-                  <a:pt x="2158440" y="1059644"/>
-                </a:lnTo>
-                <a:lnTo>
-                  <a:pt x="1997992" y="1029540"/>
-                </a:lnTo>
-                <a:lnTo>
-                  <a:pt x="1841328" y="997028"/>
-                </a:lnTo>
-                <a:lnTo>
-                  <a:pt x="1688738" y="962108"/>
-                </a:lnTo>
-                <a:lnTo>
-                  <a:pt x="1540513" y="924780"/>
-                </a:lnTo>
-                <a:lnTo>
-                  <a:pt x="1396944" y="885043"/>
-                </a:lnTo>
-                <a:lnTo>
-                  <a:pt x="1258321" y="842898"/>
-                </a:lnTo>
-                <a:lnTo>
-                  <a:pt x="1124937" y="798345"/>
-                </a:lnTo>
-                <a:lnTo>
-                  <a:pt x="997082" y="751384"/>
-                </a:lnTo>
-                <a:lnTo>
-                  <a:pt x="875046" y="702014"/>
-                </a:lnTo>
-                <a:lnTo>
-                  <a:pt x="759122" y="650236"/>
-                </a:lnTo>
-                <a:lnTo>
-                  <a:pt x="649599" y="596050"/>
-                </a:lnTo>
-                <a:lnTo>
-                  <a:pt x="546770" y="539455"/>
-                </a:lnTo>
-                <a:lnTo>
-                  <a:pt x="450924" y="480452"/>
-                </a:lnTo>
-                <a:lnTo>
-                  <a:pt x="362354" y="419041"/>
-                </a:lnTo>
-                <a:lnTo>
-                  <a:pt x="281349" y="355221"/>
-                </a:lnTo>
-                <a:lnTo>
-                  <a:pt x="208201" y="288994"/>
-                </a:lnTo>
-                <a:lnTo>
-                  <a:pt x="143202" y="220358"/>
-                </a:lnTo>
-                <a:lnTo>
-                  <a:pt x="86641" y="149313"/>
-                </a:lnTo>
-                <a:lnTo>
-                  <a:pt x="38810" y="75861"/>
+                  <a:pt x="0" y="694944"/>
                 </a:lnTo>
                 <a:lnTo>
                   <a:pt x="0" y="0"/>
@@ -4772,7 +4697,7 @@
       </p:sp>
       <p:sp>
         <p:nvSpPr>
-          <p:cNvPr id="14" name="Oval 13"/>
+          <p:cNvPr id="23" name="Oval 22"/>
           <p:cNvSpPr/>
           <p:nvPr/>
         </p:nvSpPr>
@@ -4817,7 +4742,7 @@
       </p:sp>
       <p:sp>
         <p:nvSpPr>
-          <p:cNvPr id="15" name="TextBox 14"/>
+          <p:cNvPr id="24" name="TextBox 23"/>
           <p:cNvSpPr txBox="1"/>
           <p:nvPr/>
         </p:nvSpPr>
@@ -4852,7 +4777,7 @@
       </p:sp>
       <p:sp>
         <p:nvSpPr>
-          <p:cNvPr id="16" name="Oval 15"/>
+          <p:cNvPr id="25" name="Oval 24"/>
           <p:cNvSpPr/>
           <p:nvPr/>
         </p:nvSpPr>
@@ -4897,7 +4822,7 @@
       </p:sp>
       <p:sp>
         <p:nvSpPr>
-          <p:cNvPr id="17" name="TextBox 16"/>
+          <p:cNvPr id="26" name="TextBox 25"/>
           <p:cNvSpPr txBox="1"/>
           <p:nvPr/>
         </p:nvSpPr>
@@ -4944,7 +4869,7 @@
       </p:sp>
       <p:sp>
         <p:nvSpPr>
-          <p:cNvPr id="18" name="Oval 17"/>
+          <p:cNvPr id="27" name="Oval 26"/>
           <p:cNvSpPr/>
           <p:nvPr/>
         </p:nvSpPr>
@@ -4989,7 +4914,7 @@
       </p:sp>
       <p:sp>
         <p:nvSpPr>
-          <p:cNvPr id="19" name="TextBox 18"/>
+          <p:cNvPr id="28" name="TextBox 27"/>
           <p:cNvSpPr txBox="1"/>
           <p:nvPr/>
         </p:nvSpPr>
@@ -5036,7 +4961,7 @@
       </p:sp>
       <p:sp>
         <p:nvSpPr>
-          <p:cNvPr id="20" name="Oval 19"/>
+          <p:cNvPr id="29" name="Oval 28"/>
           <p:cNvSpPr/>
           <p:nvPr/>
         </p:nvSpPr>
@@ -5081,7 +5006,7 @@
       </p:sp>
       <p:sp>
         <p:nvSpPr>
-          <p:cNvPr id="21" name="TextBox 20"/>
+          <p:cNvPr id="30" name="TextBox 29"/>
           <p:cNvSpPr txBox="1"/>
           <p:nvPr/>
         </p:nvSpPr>
@@ -5128,7 +5053,7 @@
       </p:sp>
       <p:sp>
         <p:nvSpPr>
-          <p:cNvPr id="22" name="Oval 21"/>
+          <p:cNvPr id="31" name="Oval 30"/>
           <p:cNvSpPr/>
           <p:nvPr/>
         </p:nvSpPr>
@@ -5173,7 +5098,7 @@
       </p:sp>
       <p:sp>
         <p:nvSpPr>
-          <p:cNvPr id="23" name="TextBox 22"/>
+          <p:cNvPr id="32" name="TextBox 31"/>
           <p:cNvSpPr txBox="1"/>
           <p:nvPr/>
         </p:nvSpPr>
@@ -5220,7 +5145,7 @@
       </p:sp>
       <p:sp>
         <p:nvSpPr>
-          <p:cNvPr id="24" name="Oval 23"/>
+          <p:cNvPr id="33" name="Oval 32"/>
           <p:cNvSpPr/>
           <p:nvPr/>
         </p:nvSpPr>
@@ -5267,7 +5192,7 @@
       </p:sp>
       <p:sp>
         <p:nvSpPr>
-          <p:cNvPr id="25" name="Oval 24"/>
+          <p:cNvPr id="34" name="Oval 33"/>
           <p:cNvSpPr/>
           <p:nvPr/>
         </p:nvSpPr>
@@ -5314,7 +5239,7 @@
       </p:sp>
       <p:sp>
         <p:nvSpPr>
-          <p:cNvPr id="26" name="Oval 25"/>
+          <p:cNvPr id="35" name="Oval 34"/>
           <p:cNvSpPr/>
           <p:nvPr/>
         </p:nvSpPr>
@@ -5361,7 +5286,7 @@
       </p:sp>
       <p:sp>
         <p:nvSpPr>
-          <p:cNvPr id="27" name="TextBox 26"/>
+          <p:cNvPr id="36" name="TextBox 35"/>
           <p:cNvSpPr txBox="1"/>
           <p:nvPr/>
         </p:nvSpPr>
@@ -5396,13 +5321,13 @@
       </p:sp>
       <p:sp>
         <p:nvSpPr>
-          <p:cNvPr id="28" name="Oval 27"/>
+          <p:cNvPr id="37" name="Oval 36"/>
           <p:cNvSpPr/>
           <p:nvPr/>
         </p:nvSpPr>
         <p:spPr>
           <a:xfrm>
-            <a:off x="7388352" y="1570015"/>
+            <a:off x="1078992" y="1673352"/>
             <a:ext cx="676656" cy="676656"/>
           </a:xfrm>
           <a:prstGeom prst="ellipse">
@@ -5443,13 +5368,13 @@
       </p:sp>
       <p:sp>
         <p:nvSpPr>
-          <p:cNvPr id="29" name="TextBox 28"/>
+          <p:cNvPr id="38" name="TextBox 37"/>
           <p:cNvSpPr txBox="1"/>
           <p:nvPr/>
         </p:nvSpPr>
         <p:spPr>
           <a:xfrm>
-            <a:off x="6903719" y="2292391"/>
+            <a:off x="594360" y="1316736"/>
             <a:ext cx="1645920" cy="310896"/>
           </a:xfrm>
           <a:prstGeom prst="rect">
@@ -5478,13 +5403,13 @@
       </p:sp>
       <p:sp>
         <p:nvSpPr>
-          <p:cNvPr id="30" name="Oval 29"/>
+          <p:cNvPr id="39" name="Oval 38"/>
           <p:cNvSpPr/>
           <p:nvPr/>
         </p:nvSpPr>
         <p:spPr>
           <a:xfrm>
-            <a:off x="7882127" y="1441999"/>
+            <a:off x="914400" y="2130552"/>
             <a:ext cx="347472" cy="347472"/>
           </a:xfrm>
           <a:prstGeom prst="ellipse">
@@ -5525,13 +5450,13 @@
       </p:sp>
       <p:sp>
         <p:nvSpPr>
-          <p:cNvPr id="31" name="Oval 30"/>
+          <p:cNvPr id="40" name="Oval 39"/>
           <p:cNvSpPr/>
           <p:nvPr/>
         </p:nvSpPr>
         <p:spPr>
           <a:xfrm>
-            <a:off x="5811012" y="4782778"/>
+            <a:off x="7388352" y="4873752"/>
             <a:ext cx="676656" cy="676656"/>
           </a:xfrm>
           <a:prstGeom prst="ellipse">
@@ -5572,13 +5497,13 @@
       </p:sp>
       <p:sp>
         <p:nvSpPr>
-          <p:cNvPr id="32" name="TextBox 31"/>
+          <p:cNvPr id="41" name="TextBox 40"/>
           <p:cNvSpPr txBox="1"/>
           <p:nvPr/>
         </p:nvSpPr>
         <p:spPr>
           <a:xfrm>
-            <a:off x="5326379" y="5505154"/>
+            <a:off x="6903719" y="5596128"/>
             <a:ext cx="1645920" cy="310896"/>
           </a:xfrm>
           <a:prstGeom prst="rect">
@@ -5607,7 +5532,7 @@
       </p:sp>
       <p:sp>
         <p:nvSpPr>
-          <p:cNvPr id="33" name="TextBox 32"/>
+          <p:cNvPr id="42" name="TextBox 41"/>
           <p:cNvSpPr txBox="1"/>
           <p:nvPr/>
         </p:nvSpPr>
@@ -5642,10 +5567,10 @@
       </p:sp>
       <p:pic>
         <p:nvPicPr>
-          <p:cNvPr id="35" name="icon file-text" descr="file text icon">
+          <p:cNvPr id="44" name="icon file-text" descr="file text icon">
             <a:extLst>
               <a:ext uri="{FF2B5EF4-FFF2-40B4-BE49-F238E27FC236}">
-                <a16:creationId xmlns:a16="http://schemas.microsoft.com/office/drawing/2014/main" id="{61668D91-F213-89CF-E578-3E3B5E5EF7EB}"/>
+                <a16:creationId xmlns:a16="http://schemas.microsoft.com/office/drawing/2014/main" id="{864E1B0F-D150-F29B-AEFB-EECE619C31BC}"/>
               </a:ext>
             </a:extLst>
           </p:cNvPr>
@@ -5678,10 +5603,10 @@
       </p:pic>
       <p:pic>
         <p:nvPicPr>
-          <p:cNvPr id="37" name="icon messages-square" descr="messages square icon">
+          <p:cNvPr id="46" name="icon messages-square" descr="messages square icon">
             <a:extLst>
               <a:ext uri="{FF2B5EF4-FFF2-40B4-BE49-F238E27FC236}">
-                <a16:creationId xmlns:a16="http://schemas.microsoft.com/office/drawing/2014/main" id="{953F9705-B944-4896-6DD3-035AB2378804}"/>
+                <a16:creationId xmlns:a16="http://schemas.microsoft.com/office/drawing/2014/main" id="{BABD6173-17ED-5932-905D-07034AE6A6C1}"/>
               </a:ext>
             </a:extLst>
           </p:cNvPr>
@@ -5714,10 +5639,10 @@
       </p:pic>
       <p:pic>
         <p:nvPicPr>
-          <p:cNvPr id="39" name="icon notebook-pen" descr="notebook pen icon">
+          <p:cNvPr id="48" name="icon notebook-pen" descr="notebook pen icon">
             <a:extLst>
               <a:ext uri="{FF2B5EF4-FFF2-40B4-BE49-F238E27FC236}">
-                <a16:creationId xmlns:a16="http://schemas.microsoft.com/office/drawing/2014/main" id="{E1E10CDC-0FAB-DCB1-5D94-A0324002B20F}"/>
+                <a16:creationId xmlns:a16="http://schemas.microsoft.com/office/drawing/2014/main" id="{46B2C76E-038E-D747-3386-CBF6DB0883C3}"/>
               </a:ext>
             </a:extLst>
           </p:cNvPr>
@@ -5750,10 +5675,10 @@
       </p:pic>
       <p:pic>
         <p:nvPicPr>
-          <p:cNvPr id="41" name="icon list-checks" descr="list checks icon">
+          <p:cNvPr id="50" name="icon list-checks" descr="list checks icon">
             <a:extLst>
               <a:ext uri="{FF2B5EF4-FFF2-40B4-BE49-F238E27FC236}">
-                <a16:creationId xmlns:a16="http://schemas.microsoft.com/office/drawing/2014/main" id="{3F49A8DF-BE48-9D43-3167-91AB80CAF616}"/>
+                <a16:creationId xmlns:a16="http://schemas.microsoft.com/office/drawing/2014/main" id="{8E126966-DD60-7BEB-A77B-0DBCE0B10B32}"/>
               </a:ext>
             </a:extLst>
           </p:cNvPr>
@@ -5786,10 +5711,10 @@
       </p:pic>
       <p:pic>
         <p:nvPicPr>
-          <p:cNvPr id="43" name="icon boxes" descr="boxes icon">
+          <p:cNvPr id="52" name="icon boxes" descr="boxes icon">
             <a:extLst>
               <a:ext uri="{FF2B5EF4-FFF2-40B4-BE49-F238E27FC236}">
-                <a16:creationId xmlns:a16="http://schemas.microsoft.com/office/drawing/2014/main" id="{F926440A-7B37-05B0-3D5D-CB4135578856}"/>
+                <a16:creationId xmlns:a16="http://schemas.microsoft.com/office/drawing/2014/main" id="{F7FD5EC1-403F-F1FB-08C6-7238604E9EB2}"/>
               </a:ext>
             </a:extLst>
           </p:cNvPr>
@@ -5822,10 +5747,10 @@
       </p:pic>
       <p:pic>
         <p:nvPicPr>
-          <p:cNvPr id="45" name="icon book-open" descr="book open icon">
+          <p:cNvPr id="54" name="icon book-open" descr="book open icon">
             <a:extLst>
               <a:ext uri="{FF2B5EF4-FFF2-40B4-BE49-F238E27FC236}">
-                <a16:creationId xmlns:a16="http://schemas.microsoft.com/office/drawing/2014/main" id="{A0362B2D-658B-BC6B-531A-6541C8C1F112}"/>
+                <a16:creationId xmlns:a16="http://schemas.microsoft.com/office/drawing/2014/main" id="{C8586F4F-0013-DE75-B866-DA0830DF35B8}"/>
               </a:ext>
             </a:extLst>
           </p:cNvPr>
@@ -5858,10 +5783,10 @@
       </p:pic>
       <p:pic>
         <p:nvPicPr>
-          <p:cNvPr id="47" name="icon flame" descr="flame icon">
+          <p:cNvPr id="56" name="icon flame" descr="flame icon">
             <a:extLst>
               <a:ext uri="{FF2B5EF4-FFF2-40B4-BE49-F238E27FC236}">
-                <a16:creationId xmlns:a16="http://schemas.microsoft.com/office/drawing/2014/main" id="{92162586-60B8-E0EF-247B-3245AEFD09CB}"/>
+                <a16:creationId xmlns:a16="http://schemas.microsoft.com/office/drawing/2014/main" id="{053058BD-3384-9BAD-2011-F0315A769DC6}"/>
               </a:ext>
             </a:extLst>
           </p:cNvPr>
@@ -5894,10 +5819,10 @@
       </p:pic>
       <p:pic>
         <p:nvPicPr>
-          <p:cNvPr id="49" name="icon snowflake" descr="snowflake icon">
+          <p:cNvPr id="58" name="icon snowflake" descr="snowflake icon">
             <a:extLst>
               <a:ext uri="{FF2B5EF4-FFF2-40B4-BE49-F238E27FC236}">
-                <a16:creationId xmlns:a16="http://schemas.microsoft.com/office/drawing/2014/main" id="{59ADFD1A-FBA3-F887-9396-8F3D0B6D190A}"/>
+                <a16:creationId xmlns:a16="http://schemas.microsoft.com/office/drawing/2014/main" id="{D42D3EAD-4C74-BC2F-1437-3A98E1FFAD32}"/>
               </a:ext>
             </a:extLst>
           </p:cNvPr>
@@ -5930,10 +5855,10 @@
       </p:pic>
       <p:pic>
         <p:nvPicPr>
-          <p:cNvPr id="51" name="icon camera" descr="camera icon">
+          <p:cNvPr id="60" name="icon camera" descr="camera icon">
             <a:extLst>
               <a:ext uri="{FF2B5EF4-FFF2-40B4-BE49-F238E27FC236}">
-                <a16:creationId xmlns:a16="http://schemas.microsoft.com/office/drawing/2014/main" id="{7CFE4560-9F65-0A7F-D139-97069F321935}"/>
+                <a16:creationId xmlns:a16="http://schemas.microsoft.com/office/drawing/2014/main" id="{14BE57C1-67AD-9138-FF52-0D7C64480E2E}"/>
               </a:ext>
             </a:extLst>
           </p:cNvPr>
@@ -5966,10 +5891,10 @@
       </p:pic>
       <p:pic>
         <p:nvPicPr>
-          <p:cNvPr id="53" name="icon sparkles" descr="sparkles icon">
+          <p:cNvPr id="62" name="icon sparkles" descr="sparkles icon">
             <a:extLst>
               <a:ext uri="{FF2B5EF4-FFF2-40B4-BE49-F238E27FC236}">
-                <a16:creationId xmlns:a16="http://schemas.microsoft.com/office/drawing/2014/main" id="{49E8423E-F81F-1731-A31C-46A6CB00D6FB}"/>
+                <a16:creationId xmlns:a16="http://schemas.microsoft.com/office/drawing/2014/main" id="{0D8B1576-912F-D8D2-27A8-BD4F2E30CA21}"/>
               </a:ext>
             </a:extLst>
           </p:cNvPr>
@@ -5992,7 +5917,7 @@
         </p:blipFill>
         <p:spPr>
           <a:xfrm>
-            <a:off x="7543800" y="1725463"/>
+            <a:off x="1234440" y="1828800"/>
             <a:ext cx="365760" cy="365760"/>
           </a:xfrm>
           <a:prstGeom prst="rect">
@@ -6002,10 +5927,10 @@
       </p:pic>
       <p:pic>
         <p:nvPicPr>
-          <p:cNvPr id="55" name="icon user-check" descr="user check icon">
+          <p:cNvPr id="64" name="icon user-check" descr="user check icon">
             <a:extLst>
               <a:ext uri="{FF2B5EF4-FFF2-40B4-BE49-F238E27FC236}">
-                <a16:creationId xmlns:a16="http://schemas.microsoft.com/office/drawing/2014/main" id="{2A1B81D3-02ED-A1C2-48D9-EDCE9B82FFC9}"/>
+                <a16:creationId xmlns:a16="http://schemas.microsoft.com/office/drawing/2014/main" id="{87C6DBAC-CF11-9027-536B-47A15AE17D86}"/>
               </a:ext>
             </a:extLst>
           </p:cNvPr>
@@ -6028,7 +5953,7 @@
         </p:blipFill>
         <p:spPr>
           <a:xfrm>
-            <a:off x="7955280" y="1515151"/>
+            <a:off x="987552" y="2203704"/>
             <a:ext cx="201168" cy="201168"/>
           </a:xfrm>
           <a:prstGeom prst="rect">
@@ -6038,10 +5963,10 @@
       </p:pic>
       <p:pic>
         <p:nvPicPr>
-          <p:cNvPr id="57" name="icon search" descr="search icon">
+          <p:cNvPr id="66" name="icon search" descr="search icon">
             <a:extLst>
               <a:ext uri="{FF2B5EF4-FFF2-40B4-BE49-F238E27FC236}">
-                <a16:creationId xmlns:a16="http://schemas.microsoft.com/office/drawing/2014/main" id="{F6C83456-8FAB-BFB8-6FAF-644F0E75ACA5}"/>
+                <a16:creationId xmlns:a16="http://schemas.microsoft.com/office/drawing/2014/main" id="{6B01E87B-3AA9-97EF-4C28-E652C6BAFE90}"/>
               </a:ext>
             </a:extLst>
           </p:cNvPr>
@@ -6064,7 +5989,7 @@
         </p:blipFill>
         <p:spPr>
           <a:xfrm>
-            <a:off x="5966460" y="4938226"/>
+            <a:off x="7543800" y="5029200"/>
             <a:ext cx="365760" cy="365760"/>
           </a:xfrm>
           <a:prstGeom prst="rect">
@@ -9194,7 +9119,7 @@
           <p:cNvPr id="65" name="icon notebook-pen" descr="notebook pen icon">
             <a:extLst>
               <a:ext uri="{FF2B5EF4-FFF2-40B4-BE49-F238E27FC236}">
-                <a16:creationId xmlns:a16="http://schemas.microsoft.com/office/drawing/2014/main" id="{C6363B6C-DA04-9247-41A7-DF7E61E92B4D}"/>
+                <a16:creationId xmlns:a16="http://schemas.microsoft.com/office/drawing/2014/main" id="{3DBBB61C-FB5F-6E26-2331-C9E0A89DB26F}"/>
               </a:ext>
             </a:extLst>
           </p:cNvPr>
@@ -9230,7 +9155,7 @@
           <p:cNvPr id="67" name="icon folder-open" descr="folder open icon">
             <a:extLst>
               <a:ext uri="{FF2B5EF4-FFF2-40B4-BE49-F238E27FC236}">
-                <a16:creationId xmlns:a16="http://schemas.microsoft.com/office/drawing/2014/main" id="{2B906073-E64F-4B77-7E70-64E9BAB9286D}"/>
+                <a16:creationId xmlns:a16="http://schemas.microsoft.com/office/drawing/2014/main" id="{BDD98062-0A7F-C521-FADE-C64564F1BB05}"/>
               </a:ext>
             </a:extLst>
           </p:cNvPr>
@@ -9266,7 +9191,7 @@
           <p:cNvPr id="69" name="icon hourglass" descr="hourglass icon">
             <a:extLst>
               <a:ext uri="{FF2B5EF4-FFF2-40B4-BE49-F238E27FC236}">
-                <a16:creationId xmlns:a16="http://schemas.microsoft.com/office/drawing/2014/main" id="{2327D920-3B04-EC6F-2327-941B49F3CDCE}"/>
+                <a16:creationId xmlns:a16="http://schemas.microsoft.com/office/drawing/2014/main" id="{98CC4752-ACAB-28E3-8B1E-DC2FF024FF25}"/>
               </a:ext>
             </a:extLst>
           </p:cNvPr>
@@ -9302,7 +9227,7 @@
           <p:cNvPr id="71" name="icon file-text" descr="file text icon">
             <a:extLst>
               <a:ext uri="{FF2B5EF4-FFF2-40B4-BE49-F238E27FC236}">
-                <a16:creationId xmlns:a16="http://schemas.microsoft.com/office/drawing/2014/main" id="{97885F22-EA95-311E-BB19-0DBD3726E4A7}"/>
+                <a16:creationId xmlns:a16="http://schemas.microsoft.com/office/drawing/2014/main" id="{BAD39808-D7D3-D784-12F3-F6C0D3DB6B5E}"/>
               </a:ext>
             </a:extLst>
           </p:cNvPr>
@@ -9338,7 +9263,7 @@
           <p:cNvPr id="73" name="icon list-checks" descr="list checks icon">
             <a:extLst>
               <a:ext uri="{FF2B5EF4-FFF2-40B4-BE49-F238E27FC236}">
-                <a16:creationId xmlns:a16="http://schemas.microsoft.com/office/drawing/2014/main" id="{EED471F6-57FE-1B3F-F1FE-4F8EEFAFC4AE}"/>
+                <a16:creationId xmlns:a16="http://schemas.microsoft.com/office/drawing/2014/main" id="{6174F31A-96F8-2F34-4FC3-F04B217359F1}"/>
               </a:ext>
             </a:extLst>
           </p:cNvPr>
@@ -9374,7 +9299,7 @@
           <p:cNvPr id="75" name="icon folder-open" descr="folder open icon">
             <a:extLst>
               <a:ext uri="{FF2B5EF4-FFF2-40B4-BE49-F238E27FC236}">
-                <a16:creationId xmlns:a16="http://schemas.microsoft.com/office/drawing/2014/main" id="{F76BF343-5868-8589-4D88-A309B20CE493}"/>
+                <a16:creationId xmlns:a16="http://schemas.microsoft.com/office/drawing/2014/main" id="{3079C87A-EBF5-0B15-DE98-0424C98D3C27}"/>
               </a:ext>
             </a:extLst>
           </p:cNvPr>
@@ -9410,7 +9335,7 @@
           <p:cNvPr id="77" name="icon hourglass" descr="hourglass icon">
             <a:extLst>
               <a:ext uri="{FF2B5EF4-FFF2-40B4-BE49-F238E27FC236}">
-                <a16:creationId xmlns:a16="http://schemas.microsoft.com/office/drawing/2014/main" id="{847D92CD-3183-754A-5395-13CCB807BD38}"/>
+                <a16:creationId xmlns:a16="http://schemas.microsoft.com/office/drawing/2014/main" id="{F81B3C03-A853-A2A3-2A38-7887C0A478A7}"/>
               </a:ext>
             </a:extLst>
           </p:cNvPr>
@@ -9446,7 +9371,7 @@
           <p:cNvPr id="79" name="icon file-text" descr="file text icon">
             <a:extLst>
               <a:ext uri="{FF2B5EF4-FFF2-40B4-BE49-F238E27FC236}">
-                <a16:creationId xmlns:a16="http://schemas.microsoft.com/office/drawing/2014/main" id="{FE00C00C-BBDD-9918-D6C8-1C019857877C}"/>
+                <a16:creationId xmlns:a16="http://schemas.microsoft.com/office/drawing/2014/main" id="{8C858FA8-32E6-B0ED-A8A5-01260C9D17AE}"/>
               </a:ext>
             </a:extLst>
           </p:cNvPr>
@@ -9482,7 +9407,7 @@
           <p:cNvPr id="81" name="icon boxes" descr="boxes icon">
             <a:extLst>
               <a:ext uri="{FF2B5EF4-FFF2-40B4-BE49-F238E27FC236}">
-                <a16:creationId xmlns:a16="http://schemas.microsoft.com/office/drawing/2014/main" id="{224967DC-780A-5A9E-E9D3-7E63D649D62B}"/>
+                <a16:creationId xmlns:a16="http://schemas.microsoft.com/office/drawing/2014/main" id="{0803EF81-3629-4722-1879-4FE6F8D5D9A1}"/>
               </a:ext>
             </a:extLst>
           </p:cNvPr>
@@ -9518,7 +9443,7 @@
           <p:cNvPr id="83" name="icon folder-open" descr="folder open icon">
             <a:extLst>
               <a:ext uri="{FF2B5EF4-FFF2-40B4-BE49-F238E27FC236}">
-                <a16:creationId xmlns:a16="http://schemas.microsoft.com/office/drawing/2014/main" id="{C908D301-DB80-10DD-6F03-F1B4B2EB2104}"/>
+                <a16:creationId xmlns:a16="http://schemas.microsoft.com/office/drawing/2014/main" id="{7E60D535-1206-EFB2-B6BC-881D27D862B0}"/>
               </a:ext>
             </a:extLst>
           </p:cNvPr>
@@ -9554,7 +9479,7 @@
           <p:cNvPr id="85" name="icon hourglass" descr="hourglass icon">
             <a:extLst>
               <a:ext uri="{FF2B5EF4-FFF2-40B4-BE49-F238E27FC236}">
-                <a16:creationId xmlns:a16="http://schemas.microsoft.com/office/drawing/2014/main" id="{F48D6BBF-501C-9B59-0107-C33393578413}"/>
+                <a16:creationId xmlns:a16="http://schemas.microsoft.com/office/drawing/2014/main" id="{CE82C90A-835D-9F37-0058-96970C2777EC}"/>
               </a:ext>
             </a:extLst>
           </p:cNvPr>
@@ -9590,7 +9515,7 @@
           <p:cNvPr id="87" name="icon file-text" descr="file text icon">
             <a:extLst>
               <a:ext uri="{FF2B5EF4-FFF2-40B4-BE49-F238E27FC236}">
-                <a16:creationId xmlns:a16="http://schemas.microsoft.com/office/drawing/2014/main" id="{0ADECE7A-2FB0-4A48-6BF9-F4016A6B8696}"/>
+                <a16:creationId xmlns:a16="http://schemas.microsoft.com/office/drawing/2014/main" id="{1246FACE-805A-92B2-34F6-0F42105757E3}"/>
               </a:ext>
             </a:extLst>
           </p:cNvPr>
@@ -9626,7 +9551,7 @@
           <p:cNvPr id="89" name="icon book-open" descr="book open icon">
             <a:extLst>
               <a:ext uri="{FF2B5EF4-FFF2-40B4-BE49-F238E27FC236}">
-                <a16:creationId xmlns:a16="http://schemas.microsoft.com/office/drawing/2014/main" id="{9033F62B-DD6B-D94F-D229-8720A0E273F3}"/>
+                <a16:creationId xmlns:a16="http://schemas.microsoft.com/office/drawing/2014/main" id="{35235251-D0AB-03AD-2BE8-3625BD1FE6FA}"/>
               </a:ext>
             </a:extLst>
           </p:cNvPr>
@@ -9662,7 +9587,7 @@
           <p:cNvPr id="91" name="icon folder-open" descr="folder open icon">
             <a:extLst>
               <a:ext uri="{FF2B5EF4-FFF2-40B4-BE49-F238E27FC236}">
-                <a16:creationId xmlns:a16="http://schemas.microsoft.com/office/drawing/2014/main" id="{5316EA8B-05BB-87CC-0E4C-9E4E89EA6EC8}"/>
+                <a16:creationId xmlns:a16="http://schemas.microsoft.com/office/drawing/2014/main" id="{E0A1C567-D3D6-BBFD-72BC-14DC671706FB}"/>
               </a:ext>
             </a:extLst>
           </p:cNvPr>
@@ -9698,7 +9623,7 @@
           <p:cNvPr id="93" name="icon hourglass" descr="hourglass icon">
             <a:extLst>
               <a:ext uri="{FF2B5EF4-FFF2-40B4-BE49-F238E27FC236}">
-                <a16:creationId xmlns:a16="http://schemas.microsoft.com/office/drawing/2014/main" id="{55C13325-E587-42F3-CFC0-AA9CD02CD339}"/>
+                <a16:creationId xmlns:a16="http://schemas.microsoft.com/office/drawing/2014/main" id="{DF39D3D1-B8C0-019A-799E-964BDAE44D3F}"/>
               </a:ext>
             </a:extLst>
           </p:cNvPr>
@@ -9734,7 +9659,7 @@
           <p:cNvPr id="95" name="icon file-text" descr="file text icon">
             <a:extLst>
               <a:ext uri="{FF2B5EF4-FFF2-40B4-BE49-F238E27FC236}">
-                <a16:creationId xmlns:a16="http://schemas.microsoft.com/office/drawing/2014/main" id="{CB66BB42-3CF1-95C6-5354-95928EBE670C}"/>
+                <a16:creationId xmlns:a16="http://schemas.microsoft.com/office/drawing/2014/main" id="{D9D5A74B-32D2-AD53-D4F5-C96259D19BAC}"/>
               </a:ext>
             </a:extLst>
           </p:cNvPr>
@@ -9770,7 +9695,7 @@
           <p:cNvPr id="97" name="icon search" descr="search icon">
             <a:extLst>
               <a:ext uri="{FF2B5EF4-FFF2-40B4-BE49-F238E27FC236}">
-                <a16:creationId xmlns:a16="http://schemas.microsoft.com/office/drawing/2014/main" id="{195709C4-A29D-9D1F-3460-BCE0B07A642E}"/>
+                <a16:creationId xmlns:a16="http://schemas.microsoft.com/office/drawing/2014/main" id="{EC38854F-4B72-6436-B7BE-75C71D6E3D4B}"/>
               </a:ext>
             </a:extLst>
           </p:cNvPr>
@@ -9806,7 +9731,7 @@
           <p:cNvPr id="99" name="icon camera" descr="camera icon">
             <a:extLst>
               <a:ext uri="{FF2B5EF4-FFF2-40B4-BE49-F238E27FC236}">
-                <a16:creationId xmlns:a16="http://schemas.microsoft.com/office/drawing/2014/main" id="{83C42EDD-EFCE-44DC-DCD3-9D1A6597F175}"/>
+                <a16:creationId xmlns:a16="http://schemas.microsoft.com/office/drawing/2014/main" id="{466B512C-A6A5-51D2-E960-715319751E6B}"/>
               </a:ext>
             </a:extLst>
           </p:cNvPr>
@@ -9842,7 +9767,7 @@
           <p:cNvPr id="101" name="icon sparkles" descr="sparkles icon">
             <a:extLst>
               <a:ext uri="{FF2B5EF4-FFF2-40B4-BE49-F238E27FC236}">
-                <a16:creationId xmlns:a16="http://schemas.microsoft.com/office/drawing/2014/main" id="{91754C1E-13F6-F25B-3BAA-2DD870EFBCDE}"/>
+                <a16:creationId xmlns:a16="http://schemas.microsoft.com/office/drawing/2014/main" id="{8629DDD6-8B41-42C5-C4A2-68EE78608ACA}"/>
               </a:ext>
             </a:extLst>
           </p:cNvPr>
@@ -9878,7 +9803,7 @@
           <p:cNvPr id="103" name="icon trending-up" descr="trending up icon">
             <a:extLst>
               <a:ext uri="{FF2B5EF4-FFF2-40B4-BE49-F238E27FC236}">
-                <a16:creationId xmlns:a16="http://schemas.microsoft.com/office/drawing/2014/main" id="{978E81E1-4E5F-D9C8-B9C0-B2BFE965F933}"/>
+                <a16:creationId xmlns:a16="http://schemas.microsoft.com/office/drawing/2014/main" id="{C70AECB7-F5CE-3D30-C4F3-51B7853DAC74}"/>
               </a:ext>
             </a:extLst>
           </p:cNvPr>
@@ -9914,7 +9839,7 @@
           <p:cNvPr id="105" name="icon scale" descr="scale icon">
             <a:extLst>
               <a:ext uri="{FF2B5EF4-FFF2-40B4-BE49-F238E27FC236}">
-                <a16:creationId xmlns:a16="http://schemas.microsoft.com/office/drawing/2014/main" id="{7D9E5097-6798-B89D-6F3A-DD5A2A56251F}"/>
+                <a16:creationId xmlns:a16="http://schemas.microsoft.com/office/drawing/2014/main" id="{3A89CF81-D623-57B0-95CB-6F6500A7D91B}"/>
               </a:ext>
             </a:extLst>
           </p:cNvPr>
@@ -9950,7 +9875,7 @@
           <p:cNvPr id="107" name="icon trash-2" descr="trash 2 icon">
             <a:extLst>
               <a:ext uri="{FF2B5EF4-FFF2-40B4-BE49-F238E27FC236}">
-                <a16:creationId xmlns:a16="http://schemas.microsoft.com/office/drawing/2014/main" id="{B10374C6-C350-0AE5-39C0-4097269518AF}"/>
+                <a16:creationId xmlns:a16="http://schemas.microsoft.com/office/drawing/2014/main" id="{FC9CE735-0D0B-E538-107C-417B6E57E14C}"/>
               </a:ext>
             </a:extLst>
           </p:cNvPr>
@@ -9986,7 +9911,7 @@
           <p:cNvPr id="109" name="icon rocket" descr="rocket icon">
             <a:extLst>
               <a:ext uri="{FF2B5EF4-FFF2-40B4-BE49-F238E27FC236}">
-                <a16:creationId xmlns:a16="http://schemas.microsoft.com/office/drawing/2014/main" id="{751ECD32-F31B-6E86-6F9E-1A901E50B22B}"/>
+                <a16:creationId xmlns:a16="http://schemas.microsoft.com/office/drawing/2014/main" id="{C7951127-6BF8-AE4A-1E3C-B7A72D9DD7DC}"/>
               </a:ext>
             </a:extLst>
           </p:cNvPr>
@@ -10662,6 +10587,6 @@
 
 <file path=docMetadata/LabelInfo.xml><?xml version="1.0" encoding="utf-8"?>
 <clbl:labelList xmlns:clbl="http://schemas.microsoft.com/office/2020/mipLabelMetadata">
-  <clbl:label id="{fd526602-58c8-494f-8a3d-4d906671215d}" enabled="1" method="Standard" siteId="{8b87af7d-8647-4dc7-8df4-5f69a2011bb5}" removed="0"/>
+  <clbl:label id="{fd526602-58c8-494f-8a3d-4d906671215d}" enabled="1" method="Standard" siteId="{8b87af7d-8647-4dc7-8df4-5f69a2011bb5}" contentBits="3" removed="0"/>
 </clbl:labelList>
 </file>
</xml_diff>